<commit_message>
monte la presentacion que no era
</commit_message>
<xml_diff>
--- a/Presentacion_Mundial.pptx
+++ b/Presentacion_Mundial.pptx
@@ -4,6 +4,9 @@
   <p:sldMasterIdLst>
     <p:sldMasterId id="2147483648" r:id="rId1"/>
   </p:sldMasterIdLst>
+  <p:notesMasterIdLst>
+    <p:notesMasterId r:id="rId9"/>
+  </p:notesMasterIdLst>
   <p:sldIdLst>
     <p:sldId id="256" r:id="rId2"/>
     <p:sldId id="257" r:id="rId3"/>
@@ -13,10 +16,7 @@
     <p:sldId id="261" r:id="rId7"/>
     <p:sldId id="262" r:id="rId8"/>
   </p:sldIdLst>
-  <p:notesMasterIdLst>
-    <p:notesMasterId r:id="rId9"/>
-  </p:notesMasterIdLst>
-  <p:sldSz cx="9144000" cy="5143500"/>
+  <p:sldSz cx="9144000" cy="5143500" type="screen16x9"/>
   <p:notesSz cx="5143500" cy="9144000"/>
   <p:defaultTextStyle>
     <a:lvl1pPr marL="0" algn="l" defTabSz="914400" rtl="0" eaLnBrk="1" latinLnBrk="0" hangingPunct="1">
@@ -110,6 +110,11 @@
       </a:defRPr>
     </a:lvl9pPr>
   </p:defaultTextStyle>
+  <p:extLst>
+    <p:ext uri="{EFAFB233-063F-42B5-8137-9DF3F51BA10A}">
+      <p15:sldGuideLst xmlns:p15="http://schemas.microsoft.com/office/powerpoint/2012/main"/>
+    </p:ext>
+  </p:extLst>
 </p:presentation>
 </file>
 
@@ -135,234 +140,10 @@
           <a:chExt cx="0" cy="0"/>
         </a:xfrm>
       </p:grpSpPr>
-      <p:sp>
-        <p:nvSpPr>
-          <p:cNvPr id="2" name="Header Placeholder 1"/>
-          <p:cNvSpPr>
-            <a:spLocks noGrp="1"/>
-          </p:cNvSpPr>
-          <p:nvPr>
-            <p:ph type="hdr" sz="quarter"/>
-          </p:nvPr>
-        </p:nvSpPr>
-        <p:spPr>
-          <a:xfrm>
-            <a:off x="0" y="0"/>
-            <a:ext cx="2971800" cy="458788"/>
-          </a:xfrm>
-          <a:prstGeom prst="rect">
-            <a:avLst/>
-          </a:prstGeom>
-        </p:spPr>
-        <p:txBody>
-          <a:bodyPr vert="horz" lIns="91440" tIns="45720" rIns="91440" bIns="45720" rtlCol="0"/>
-          <a:lstStyle>
-            <a:lvl1pPr algn="l">
-              <a:defRPr sz="1200"/>
-            </a:lvl1pPr>
-          </a:lstStyle>
-          <a:p>
-            <a:endParaRPr lang="en-US"/>
-          </a:p>
-        </p:txBody>
-      </p:sp>
-      <p:sp>
-        <p:nvSpPr>
-          <p:cNvPr id="3" name="Date Placeholder 2"/>
-          <p:cNvSpPr>
-            <a:spLocks noGrp="1"/>
-          </p:cNvSpPr>
-          <p:nvPr>
-            <p:ph type="dt" idx="1"/>
-          </p:nvPr>
-        </p:nvSpPr>
-        <p:spPr>
-          <a:xfrm>
-            <a:off x="3884613" y="0"/>
-            <a:ext cx="2971800" cy="458788"/>
-          </a:xfrm>
-          <a:prstGeom prst="rect">
-            <a:avLst/>
-          </a:prstGeom>
-        </p:spPr>
-        <p:txBody>
-          <a:bodyPr vert="horz" lIns="91440" tIns="45720" rIns="91440" bIns="45720" rtlCol="0"/>
-          <a:lstStyle>
-            <a:lvl1pPr algn="r">
-              <a:defRPr sz="1200"/>
-            </a:lvl1pPr>
-          </a:lstStyle>
-          <a:p>
-            <a:fld id="{5282F153-3F37-0F45-9E97-73ACFA13230C}" type="datetimeFigureOut">
-              <a:rPr lang="en-US"/>
-              <a:t>7/23/19</a:t>
-            </a:fld>
-            <a:endParaRPr lang="en-US"/>
-          </a:p>
-        </p:txBody>
-      </p:sp>
-      <p:sp>
-        <p:nvSpPr>
-          <p:cNvPr id="4" name="Slide Image Placeholder 3"/>
-          <p:cNvSpPr>
-            <a:spLocks noGrp="1" noRot="1" noChangeAspect="1"/>
-          </p:cNvSpPr>
-          <p:nvPr>
-            <p:ph type="sldImg" idx="2"/>
-          </p:nvPr>
-        </p:nvSpPr>
-        <p:spPr>
-          <a:xfrm>
-            <a:off x="685800" y="1143000"/>
-            <a:ext cx="5486400" cy="3086100"/>
-          </a:xfrm>
-          <a:prstGeom prst="rect">
-            <a:avLst/>
-          </a:prstGeom>
-          <a:noFill/>
-          <a:ln w="12700">
-            <a:solidFill>
-              <a:prstClr val="black"/>
-            </a:solidFill>
-          </a:ln>
-        </p:spPr>
-        <p:txBody>
-          <a:bodyPr vert="horz" lIns="91440" tIns="45720" rIns="91440" bIns="45720" rtlCol="0" anchor="ctr"/>
-          <a:lstStyle/>
-          <a:p>
-            <a:endParaRPr lang="en-US"/>
-          </a:p>
-        </p:txBody>
-      </p:sp>
-      <p:sp>
-        <p:nvSpPr>
-          <p:cNvPr id="5" name="Notes Placeholder 4"/>
-          <p:cNvSpPr>
-            <a:spLocks noGrp="1"/>
-          </p:cNvSpPr>
-          <p:nvPr>
-            <p:ph type="body" sz="quarter" idx="3"/>
-          </p:nvPr>
-        </p:nvSpPr>
-        <p:spPr>
-          <a:xfrm>
-            <a:off x="685800" y="4400550"/>
-            <a:ext cx="5486400" cy="3600450"/>
-          </a:xfrm>
-          <a:prstGeom prst="rect">
-            <a:avLst/>
-          </a:prstGeom>
-        </p:spPr>
-        <p:txBody>
-          <a:bodyPr vert="horz" lIns="91440" tIns="45720" rIns="91440" bIns="45720" rtlCol="0"/>
-          <a:lstStyle/>
-          <a:p>
-            <a:pPr lvl="0"/>
-            <a:r>
-              <a:rPr lang="en-US"/>
-              <a:t>Click to edit Master text styles</a:t>
-            </a:r>
-          </a:p>
-          <a:p>
-            <a:pPr lvl="1"/>
-            <a:r>
-              <a:rPr lang="en-US"/>
-              <a:t>Second level</a:t>
-            </a:r>
-          </a:p>
-          <a:p>
-            <a:pPr lvl="2"/>
-            <a:r>
-              <a:rPr lang="en-US"/>
-              <a:t>Third level</a:t>
-            </a:r>
-          </a:p>
-          <a:p>
-            <a:pPr lvl="3"/>
-            <a:r>
-              <a:rPr lang="en-US"/>
-              <a:t>Fourth level</a:t>
-            </a:r>
-          </a:p>
-          <a:p>
-            <a:pPr lvl="4"/>
-            <a:r>
-              <a:rPr lang="en-US"/>
-              <a:t>Fifth level</a:t>
-            </a:r>
-          </a:p>
-        </p:txBody>
-      </p:sp>
-      <p:sp>
-        <p:nvSpPr>
-          <p:cNvPr id="6" name="Footer Placeholder 5"/>
-          <p:cNvSpPr>
-            <a:spLocks noGrp="1"/>
-          </p:cNvSpPr>
-          <p:nvPr>
-            <p:ph type="ftr" sz="quarter" idx="4"/>
-          </p:nvPr>
-        </p:nvSpPr>
-        <p:spPr>
-          <a:xfrm>
-            <a:off x="0" y="8685213"/>
-            <a:ext cx="2971800" cy="458787"/>
-          </a:xfrm>
-          <a:prstGeom prst="rect">
-            <a:avLst/>
-          </a:prstGeom>
-        </p:spPr>
-        <p:txBody>
-          <a:bodyPr vert="horz" lIns="91440" tIns="45720" rIns="91440" bIns="45720" rtlCol="0" anchor="b"/>
-          <a:lstStyle>
-            <a:lvl1pPr algn="l">
-              <a:defRPr sz="1200"/>
-            </a:lvl1pPr>
-          </a:lstStyle>
-          <a:p>
-            <a:endParaRPr lang="en-US"/>
-          </a:p>
-        </p:txBody>
-      </p:sp>
-      <p:sp>
-        <p:nvSpPr>
-          <p:cNvPr id="7" name="Slide Number Placeholder 6"/>
-          <p:cNvSpPr>
-            <a:spLocks noGrp="1"/>
-          </p:cNvSpPr>
-          <p:nvPr>
-            <p:ph type="sldNum" sz="quarter" idx="5"/>
-          </p:nvPr>
-        </p:nvSpPr>
-        <p:spPr>
-          <a:xfrm>
-            <a:off x="3884613" y="8685213"/>
-            <a:ext cx="2971800" cy="458787"/>
-          </a:xfrm>
-          <a:prstGeom prst="rect">
-            <a:avLst/>
-          </a:prstGeom>
-        </p:spPr>
-        <p:txBody>
-          <a:bodyPr vert="horz" lIns="91440" tIns="45720" rIns="91440" bIns="45720" rtlCol="0" anchor="b"/>
-          <a:lstStyle>
-            <a:lvl1pPr algn="r">
-              <a:defRPr sz="1200"/>
-            </a:lvl1pPr>
-          </a:lstStyle>
-          <a:p>
-            <a:fld id="{CE5E9CC1-C706-0F49-92D6-E571CC5EEA8F}" type="slidenum">
-              <a:rPr lang="en-US"/>
-              <a:t>‹#›</a:t>
-            </a:fld>
-            <a:endParaRPr lang="en-US"/>
-          </a:p>
-        </p:txBody>
-      </p:sp>
     </p:spTree>
     <p:extLst>
       <p:ext uri="{BB962C8B-B14F-4D97-AF65-F5344CB8AC3E}">
-        <p14:creationId xmlns:p14="http://schemas.microsoft.com/office/powerpoint/2010/main" val="1024086991"/>
+        <p14:creationId xmlns:p14="http://schemas.microsoft.com/office/powerpoint/2010/main" val="2525060806"/>
       </p:ext>
     </p:extLst>
   </p:cSld>
@@ -510,7 +291,6 @@
               <a:rPr lang="en-US" dirty="0"/>
               <a:t>Presentamos nuestro proyecto: el Mundial de Fútbol en Consola. El tema es arreglos y matrices, y la portada ya lo muestra: una bandera dibujada con una matriz de celdas.</a:t>
             </a:r>
-            <a:endParaRPr lang="en-US" dirty="0"/>
           </a:p>
         </p:txBody>
       </p:sp>
@@ -598,7 +378,6 @@
               <a:rPr lang="en-US" dirty="0"/>
               <a:t>Un arreglo es una lista: un dato después de otro, y lo buscamos con un índice que empieza en 0. Una matriz es un arreglo de arreglos: una tabla con filas y columnas, y la buscamos con dos índices.</a:t>
             </a:r>
-            <a:endParaRPr lang="en-US" dirty="0"/>
           </a:p>
         </p:txBody>
       </p:sp>
@@ -686,7 +465,6 @@
               <a:rPr lang="en-US" dirty="0"/>
               <a:t>El proyecto tiene cuatro partes y cada una se apoya en una estructura: las banderas en una matriz de caracteres, la tabla de posiciones en una matriz de enteros, el fixture en una matriz de textos, y la información de países en arreglos.</a:t>
             </a:r>
-            <a:endParaRPr lang="en-US" dirty="0"/>
           </a:p>
         </p:txBody>
       </p:sp>
@@ -774,7 +552,6 @@
               <a:rPr lang="en-US" dirty="0"/>
               <a:t>Cada bandera mide 10 filas por 15 columnas. Cargamos el archivo CSV en una matriz de caracteres y, para dibujar, miramos cada celda: el dígito nos dice qué color de fondo imprimir. Para los tamaños pequeños tomamos la celda del centro de cada bloque.</a:t>
             </a:r>
-            <a:endParaRPr lang="en-US" dirty="0"/>
           </a:p>
         </p:txBody>
       </p:sp>
@@ -862,7 +639,6 @@
               <a:rPr lang="en-US" dirty="0"/>
               <a:t>La tabla es una matriz de enteros: una fila por equipo y una columna por dato. Un ciclo anidado la recorre: el de afuera pasa por los equipos de la página y el de adentro por las diez columnas. En la captura editamos México a mano como ejemplo.</a:t>
             </a:r>
-            <a:endParaRPr lang="en-US" dirty="0"/>
           </a:p>
         </p:txBody>
       </p:sp>
@@ -950,7 +726,6 @@
               <a:rPr lang="en-US" dirty="0"/>
               <a:t>El fixture es una matriz de textos con 72 filas, una por partido, y 8 columnas: número, grupo, fecha, hora, los dos equipos, estadio y ciudad. Para mostrar un grupo recorremos todas las filas y solo imprimimos las que tienen la letra del grupo en la columna 1. La captura es el grupo K, donde juega Colombia.</a:t>
             </a:r>
-            <a:endParaRPr lang="en-US" dirty="0"/>
           </a:p>
         </p:txBody>
       </p:sp>
@@ -1038,7 +813,6 @@
               <a:rPr lang="en-US" dirty="0"/>
               <a:t>Lo más importante que aprendimos es pensar los datos como filas y columnas. Lo que nos falta es que la tabla se actualice sola con los resultados, un menú que junte todos los programas y guardar los datos en un archivo.</a:t>
             </a:r>
-            <a:endParaRPr lang="en-US" dirty="0"/>
           </a:p>
         </p:txBody>
       </p:sp>
@@ -1111,6 +885,11 @@
 <file path=ppt/slideMasters/slideMaster1.xml><?xml version="1.0" encoding="utf-8"?>
 <p:sldMaster xmlns:a="http://schemas.openxmlformats.org/drawingml/2006/main" xmlns:r="http://schemas.openxmlformats.org/officeDocument/2006/relationships" xmlns:p="http://schemas.openxmlformats.org/presentationml/2006/main">
   <p:cSld>
+    <p:bg>
+      <p:bgRef idx="1001">
+        <a:schemeClr val="bg1"/>
+      </p:bgRef>
+    </p:bg>
     <p:spTree>
       <p:nvGrpSpPr>
         <p:cNvPr id="1" name=""/>
@@ -1393,6 +1172,7 @@
         <a:solidFill>
           <a:srgbClr val="0B3D2E"/>
         </a:solidFill>
+        <a:effectLst/>
       </p:bgPr>
     </p:bg>
     <p:spTree>
@@ -1430,7 +1210,7 @@
           <a:bodyPr wrap="square" lIns="0" tIns="0" rIns="0" bIns="0" rtlCol="0" anchor="t"/>
           <a:lstStyle/>
           <a:p>
-            <a:pPr indent="0" marL="0">
+            <a:pPr marL="0" indent="0">
               <a:buNone/>
             </a:pPr>
             <a:r>
@@ -1447,7 +1227,7 @@
             <a:endParaRPr lang="en-US" sz="4400" dirty="0"/>
           </a:p>
           <a:p>
-            <a:pPr indent="0" marL="0">
+            <a:pPr marL="0" indent="0">
               <a:buNone/>
             </a:pPr>
             <a:r>
@@ -1486,7 +1266,7 @@
           <a:bodyPr wrap="square" lIns="0" tIns="0" rIns="0" bIns="0" rtlCol="0" anchor="ctr"/>
           <a:lstStyle/>
           <a:p>
-            <a:pPr indent="0" marL="0">
+            <a:pPr marL="0" indent="0">
               <a:buNone/>
             </a:pPr>
             <a:r>
@@ -1525,7 +1305,7 @@
           <a:bodyPr wrap="square" lIns="0" tIns="0" rIns="0" bIns="0" rtlCol="0" anchor="ctr"/>
           <a:lstStyle/>
           <a:p>
-            <a:pPr indent="0" marL="0">
+            <a:pPr marL="0" indent="0">
               <a:buNone/>
             </a:pPr>
             <a:r>
@@ -1542,7 +1322,7 @@
             <a:endParaRPr lang="en-US" sz="1600" dirty="0"/>
           </a:p>
           <a:p>
-            <a:pPr indent="0" marL="0">
+            <a:pPr marL="0" indent="0">
               <a:buNone/>
             </a:pPr>
             <a:r>
@@ -1559,7 +1339,7 @@
             <a:endParaRPr lang="en-US" sz="1600" dirty="0"/>
           </a:p>
           <a:p>
-            <a:pPr indent="0" marL="0">
+            <a:pPr marL="0" indent="0">
               <a:buNone/>
             </a:pPr>
             <a:r>
@@ -4190,7 +3970,7 @@
           <a:bodyPr wrap="square" lIns="0" tIns="0" rIns="0" bIns="0" rtlCol="0" anchor="ctr"/>
           <a:lstStyle/>
           <a:p>
-            <a:pPr algn="r" indent="0" marL="0">
+            <a:pPr marL="0" indent="0" algn="r">
               <a:buNone/>
             </a:pPr>
             <a:r>
@@ -4224,6 +4004,7 @@
         <a:solidFill>
           <a:srgbClr val="F2F5F3"/>
         </a:solidFill>
+        <a:effectLst/>
       </p:bgPr>
     </p:bg>
     <p:spTree>
@@ -4261,7 +4042,7 @@
           <a:bodyPr wrap="square" lIns="0" tIns="0" rIns="0" bIns="0" rtlCol="0" anchor="ctr"/>
           <a:lstStyle/>
           <a:p>
-            <a:pPr indent="0" marL="0">
+            <a:pPr marL="0" indent="0">
               <a:buNone/>
             </a:pPr>
             <a:r>
@@ -4327,7 +4108,7 @@
           <a:bodyPr wrap="square" lIns="0" tIns="0" rIns="0" bIns="0" rtlCol="0" anchor="ctr"/>
           <a:lstStyle/>
           <a:p>
-            <a:pPr indent="0" marL="0">
+            <a:pPr marL="0" indent="0">
               <a:buNone/>
             </a:pPr>
             <a:r>
@@ -4491,7 +4272,7 @@
           <a:bodyPr wrap="square" lIns="0" tIns="0" rIns="0" bIns="0" rtlCol="0" anchor="ctr"/>
           <a:lstStyle/>
           <a:p>
-            <a:pPr algn="ctr" indent="0" marL="0">
+            <a:pPr marL="0" indent="0" algn="ctr">
               <a:buNone/>
             </a:pPr>
             <a:r>
@@ -4530,7 +4311,7 @@
           <a:bodyPr wrap="square" lIns="0" tIns="0" rIns="0" bIns="0" rtlCol="0" anchor="ctr"/>
           <a:lstStyle/>
           <a:p>
-            <a:pPr algn="ctr" indent="0" marL="0">
+            <a:pPr marL="0" indent="0" algn="ctr">
               <a:buNone/>
             </a:pPr>
             <a:r>
@@ -4569,7 +4350,7 @@
           <a:bodyPr wrap="square" lIns="0" tIns="0" rIns="0" bIns="0" rtlCol="0" anchor="ctr"/>
           <a:lstStyle/>
           <a:p>
-            <a:pPr algn="ctr" indent="0" marL="0">
+            <a:pPr marL="0" indent="0" algn="ctr">
               <a:buNone/>
             </a:pPr>
             <a:r>
@@ -4608,7 +4389,7 @@
           <a:bodyPr wrap="square" lIns="0" tIns="0" rIns="0" bIns="0" rtlCol="0" anchor="ctr"/>
           <a:lstStyle/>
           <a:p>
-            <a:pPr algn="ctr" indent="0" marL="0">
+            <a:pPr marL="0" indent="0" algn="ctr">
               <a:buNone/>
             </a:pPr>
             <a:r>
@@ -4647,7 +4428,7 @@
           <a:bodyPr wrap="square" lIns="0" tIns="0" rIns="0" bIns="0" rtlCol="0" anchor="ctr"/>
           <a:lstStyle/>
           <a:p>
-            <a:pPr algn="ctr" indent="0" marL="0">
+            <a:pPr marL="0" indent="0" algn="ctr">
               <a:buNone/>
             </a:pPr>
             <a:r>
@@ -4686,7 +4467,7 @@
           <a:bodyPr wrap="square" lIns="0" tIns="0" rIns="0" bIns="0" rtlCol="0" anchor="t"/>
           <a:lstStyle/>
           <a:p>
-            <a:pPr indent="0" marL="0">
+            <a:pPr marL="0" indent="0">
               <a:buNone/>
             </a:pPr>
             <a:r>
@@ -4752,7 +4533,7 @@
           <a:bodyPr wrap="square" lIns="50800" tIns="50800" rIns="50800" bIns="50800" rtlCol="0" anchor="ctr"/>
           <a:lstStyle/>
           <a:p>
-            <a:pPr indent="0" marL="0">
+            <a:pPr marL="0" indent="0">
               <a:buNone/>
             </a:pPr>
             <a:r>
@@ -4769,7 +4550,7 @@
             <a:endParaRPr lang="en-US" sz="1000" dirty="0"/>
           </a:p>
           <a:p>
-            <a:pPr indent="0" marL="0">
+            <a:pPr marL="0" indent="0">
               <a:buNone/>
             </a:pPr>
             <a:r>
@@ -4786,7 +4567,7 @@
             <a:endParaRPr lang="en-US" sz="1000" dirty="0"/>
           </a:p>
           <a:p>
-            <a:pPr indent="0" marL="0">
+            <a:pPr marL="0" indent="0">
               <a:buNone/>
             </a:pPr>
             <a:r>
@@ -4800,9 +4581,6 @@
               </a:rPr>
               <a:t>paises[1]  </a:t>
             </a:r>
-            <a:pPr indent="0" marL="0">
-              <a:buNone/>
-            </a:pPr>
             <a:r>
               <a:rPr lang="en-US" sz="1000" dirty="0">
                 <a:solidFill>
@@ -4866,7 +4644,7 @@
           <a:bodyPr wrap="square" lIns="0" tIns="0" rIns="0" bIns="0" rtlCol="0" anchor="ctr"/>
           <a:lstStyle/>
           <a:p>
-            <a:pPr indent="0" marL="0">
+            <a:pPr marL="0" indent="0">
               <a:buNone/>
             </a:pPr>
             <a:r>
@@ -5280,7 +5058,7 @@
           <a:bodyPr wrap="square" lIns="0" tIns="0" rIns="0" bIns="0" rtlCol="0" anchor="t"/>
           <a:lstStyle/>
           <a:p>
-            <a:pPr indent="0" marL="0">
+            <a:pPr marL="0" indent="0">
               <a:buNone/>
             </a:pPr>
             <a:r>
@@ -5346,7 +5124,7 @@
           <a:bodyPr wrap="square" lIns="50800" tIns="50800" rIns="50800" bIns="50800" rtlCol="0" anchor="ctr"/>
           <a:lstStyle/>
           <a:p>
-            <a:pPr indent="0" marL="0">
+            <a:pPr marL="0" indent="0">
               <a:buNone/>
             </a:pPr>
             <a:r>
@@ -5363,7 +5141,7 @@
             <a:endParaRPr lang="en-US" sz="1000" dirty="0"/>
           </a:p>
           <a:p>
-            <a:pPr indent="0" marL="0">
+            <a:pPr marL="0" indent="0">
               <a:buNone/>
             </a:pPr>
             <a:r>
@@ -5377,9 +5155,6 @@
               </a:rPr>
               <a:t>tabla[0][9]  </a:t>
             </a:r>
-            <a:pPr indent="0" marL="0">
-              <a:buNone/>
-            </a:pPr>
             <a:r>
               <a:rPr lang="en-US" sz="1000" dirty="0">
                 <a:solidFill>
@@ -5411,6 +5186,7 @@
         <a:solidFill>
           <a:srgbClr val="F2F5F3"/>
         </a:solidFill>
+        <a:effectLst/>
       </p:bgPr>
     </p:bg>
     <p:spTree>
@@ -5448,7 +5224,7 @@
           <a:bodyPr wrap="square" lIns="0" tIns="0" rIns="0" bIns="0" rtlCol="0" anchor="ctr"/>
           <a:lstStyle/>
           <a:p>
-            <a:pPr indent="0" marL="0">
+            <a:pPr marL="0" indent="0">
               <a:buNone/>
             </a:pPr>
             <a:r>
@@ -5487,7 +5263,7 @@
           <a:bodyPr wrap="square" lIns="0" tIns="0" rIns="0" bIns="0" rtlCol="0" anchor="ctr"/>
           <a:lstStyle/>
           <a:p>
-            <a:pPr indent="0" marL="0">
+            <a:pPr marL="0" indent="0">
               <a:buNone/>
             </a:pPr>
             <a:r>
@@ -5559,393 +5335,7 @@
       </p:sp>
       <p:pic>
         <p:nvPicPr>
-          <p:cNvPr id="6" name="Image 0" descr="preencoded.png">    </p:cNvPr>
-          <p:cNvPicPr>
-            <a:picLocks noChangeAspect="1"/>
-          </p:cNvPicPr>
-          <p:nvPr/>
-        </p:nvPicPr>
-        <p:blipFill>
-          <a:blip r:embed="rId1"/>
-          <a:stretch>
-            <a:fillRect/>
-          </a:stretch>
-        </p:blipFill>
-        <p:spPr>
-          <a:xfrm>
-            <a:off x="850392" y="1993392"/>
-            <a:ext cx="310896" cy="310896"/>
-          </a:xfrm>
-          <a:prstGeom prst="rect">
-            <a:avLst/>
-          </a:prstGeom>
-        </p:spPr>
-      </p:pic>
-      <p:sp>
-        <p:nvSpPr>
-          <p:cNvPr id="7" name="Text 4"/>
-          <p:cNvSpPr txBox="1"/>
-          <p:nvPr/>
-        </p:nvSpPr>
-        <p:spPr>
-          <a:xfrm>
-            <a:off x="1508760" y="1691640"/>
-            <a:ext cx="2834640" cy="365760"/>
-          </a:xfrm>
-          <a:prstGeom prst="rect">
-            <a:avLst/>
-          </a:prstGeom>
-          <a:noFill/>
-          <a:ln/>
-        </p:spPr>
-        <p:txBody>
-          <a:bodyPr wrap="square" lIns="0" tIns="0" rIns="0" bIns="0" rtlCol="0" anchor="ctr"/>
-          <a:lstStyle/>
-          <a:p>
-            <a:pPr indent="0" marL="0">
-              <a:buNone/>
-            </a:pPr>
-            <a:r>
-              <a:rPr lang="en-US" sz="1700" b="1" dirty="0">
-                <a:solidFill>
-                  <a:srgbClr val="0B3D2E"/>
-                </a:solidFill>
-                <a:latin typeface="Cambria" pitchFamily="34" charset="0"/>
-                <a:ea typeface="Cambria" pitchFamily="34" charset="-122"/>
-                <a:cs typeface="Cambria" pitchFamily="34" charset="-120"/>
-              </a:rPr>
-              <a:t>Banderas</a:t>
-            </a:r>
-            <a:endParaRPr lang="en-US" sz="1700" dirty="0"/>
-          </a:p>
-        </p:txBody>
-      </p:sp>
-      <p:sp>
-        <p:nvSpPr>
-          <p:cNvPr id="8" name="Text 5"/>
-          <p:cNvSpPr txBox="1"/>
-          <p:nvPr/>
-        </p:nvSpPr>
-        <p:spPr>
-          <a:xfrm>
-            <a:off x="1508760" y="2057400"/>
-            <a:ext cx="2834640" cy="502920"/>
-          </a:xfrm>
-          <a:prstGeom prst="rect">
-            <a:avLst/>
-          </a:prstGeom>
-          <a:noFill/>
-          <a:ln/>
-        </p:spPr>
-        <p:txBody>
-          <a:bodyPr wrap="square" lIns="0" tIns="0" rIns="0" bIns="0" rtlCol="0" anchor="t"/>
-          <a:lstStyle/>
-          <a:p>
-            <a:pPr indent="0" marL="0">
-              <a:buNone/>
-            </a:pPr>
-            <a:r>
-              <a:rPr lang="en-US" sz="1300" dirty="0">
-                <a:solidFill>
-                  <a:srgbClr val="12261E"/>
-                </a:solidFill>
-                <a:latin typeface="Calibri" pitchFamily="34" charset="0"/>
-                <a:ea typeface="Calibri" pitchFamily="34" charset="-122"/>
-                <a:cs typeface="Calibri" pitchFamily="34" charset="-120"/>
-              </a:rPr>
-              <a:t>48 banderas en 4 tamaños, dibujadas con colores.</a:t>
-            </a:r>
-            <a:endParaRPr lang="en-US" sz="1300" dirty="0"/>
-          </a:p>
-        </p:txBody>
-      </p:sp>
-      <p:sp>
-        <p:nvSpPr>
-          <p:cNvPr id="9" name="Text 6"/>
-          <p:cNvSpPr txBox="1"/>
-          <p:nvPr/>
-        </p:nvSpPr>
-        <p:spPr>
-          <a:xfrm>
-            <a:off x="1508760" y="2578608"/>
-            <a:ext cx="2834640" cy="274320"/>
-          </a:xfrm>
-          <a:prstGeom prst="rect">
-            <a:avLst/>
-          </a:prstGeom>
-          <a:noFill/>
-          <a:ln/>
-        </p:spPr>
-        <p:txBody>
-          <a:bodyPr wrap="square" lIns="0" tIns="0" rIns="0" bIns="0" rtlCol="0" anchor="ctr"/>
-          <a:lstStyle/>
-          <a:p>
-            <a:pPr indent="0" marL="0">
-              <a:buNone/>
-            </a:pPr>
-            <a:r>
-              <a:rPr lang="en-US" sz="1200" b="1" dirty="0">
-                <a:solidFill>
-                  <a:srgbClr val="1F7A4D"/>
-                </a:solidFill>
-                <a:latin typeface="Courier New" pitchFamily="34" charset="0"/>
-                <a:ea typeface="Courier New" pitchFamily="34" charset="-122"/>
-                <a:cs typeface="Courier New" pitchFamily="34" charset="-120"/>
-              </a:rPr>
-              <a:t>char[480][15]</a:t>
-            </a:r>
-            <a:endParaRPr lang="en-US" sz="1200" dirty="0"/>
-          </a:p>
-        </p:txBody>
-      </p:sp>
-      <p:sp>
-        <p:nvSpPr>
-          <p:cNvPr id="10" name="Shape 7"/>
-          <p:cNvSpPr/>
-          <p:nvPr/>
-        </p:nvSpPr>
-        <p:spPr>
-          <a:xfrm>
-            <a:off x="4663440" y="1554480"/>
-            <a:ext cx="4023360" cy="1417320"/>
-          </a:xfrm>
-          <a:prstGeom prst="roundRect">
-            <a:avLst>
-              <a:gd name="adj" fmla="val 6452"/>
-            </a:avLst>
-          </a:prstGeom>
-          <a:solidFill>
-            <a:srgbClr val="FFFFFF"/>
-          </a:solidFill>
-          <a:ln w="12700">
-            <a:solidFill>
-              <a:srgbClr val="D5DED9"/>
-            </a:solidFill>
-            <a:prstDash val="solid"/>
-          </a:ln>
-        </p:spPr>
-      </p:sp>
-      <p:sp>
-        <p:nvSpPr>
-          <p:cNvPr id="11" name="Shape 8"/>
-          <p:cNvSpPr/>
-          <p:nvPr/>
-        </p:nvSpPr>
-        <p:spPr>
-          <a:xfrm>
-            <a:off x="4892040" y="1828800"/>
-            <a:ext cx="640080" cy="640080"/>
-          </a:xfrm>
-          <a:prstGeom prst="ellipse">
-            <a:avLst/>
-          </a:prstGeom>
-          <a:solidFill>
-            <a:srgbClr val="0B3D2E"/>
-          </a:solidFill>
-          <a:ln w="12700">
-            <a:solidFill>
-              <a:srgbClr val="0B3D2E"/>
-            </a:solidFill>
-            <a:prstDash val="solid"/>
-          </a:ln>
-        </p:spPr>
-      </p:sp>
-      <p:pic>
-        <p:nvPicPr>
-          <p:cNvPr id="12" name="Image 1" descr="preencoded.png">    </p:cNvPr>
-          <p:cNvPicPr>
-            <a:picLocks noChangeAspect="1"/>
-          </p:cNvPicPr>
-          <p:nvPr/>
-        </p:nvPicPr>
-        <p:blipFill>
-          <a:blip r:embed="rId2"/>
-          <a:stretch>
-            <a:fillRect/>
-          </a:stretch>
-        </p:blipFill>
-        <p:spPr>
-          <a:xfrm>
-            <a:off x="5056632" y="1993392"/>
-            <a:ext cx="310896" cy="310896"/>
-          </a:xfrm>
-          <a:prstGeom prst="rect">
-            <a:avLst/>
-          </a:prstGeom>
-        </p:spPr>
-      </p:pic>
-      <p:sp>
-        <p:nvSpPr>
-          <p:cNvPr id="13" name="Text 9"/>
-          <p:cNvSpPr txBox="1"/>
-          <p:nvPr/>
-        </p:nvSpPr>
-        <p:spPr>
-          <a:xfrm>
-            <a:off x="5715000" y="1691640"/>
-            <a:ext cx="2834640" cy="365760"/>
-          </a:xfrm>
-          <a:prstGeom prst="rect">
-            <a:avLst/>
-          </a:prstGeom>
-          <a:noFill/>
-          <a:ln/>
-        </p:spPr>
-        <p:txBody>
-          <a:bodyPr wrap="square" lIns="0" tIns="0" rIns="0" bIns="0" rtlCol="0" anchor="ctr"/>
-          <a:lstStyle/>
-          <a:p>
-            <a:pPr indent="0" marL="0">
-              <a:buNone/>
-            </a:pPr>
-            <a:r>
-              <a:rPr lang="en-US" sz="1700" b="1" dirty="0">
-                <a:solidFill>
-                  <a:srgbClr val="0B3D2E"/>
-                </a:solidFill>
-                <a:latin typeface="Cambria" pitchFamily="34" charset="0"/>
-                <a:ea typeface="Cambria" pitchFamily="34" charset="-122"/>
-                <a:cs typeface="Cambria" pitchFamily="34" charset="-120"/>
-              </a:rPr>
-              <a:t>Tabla de posiciones</a:t>
-            </a:r>
-            <a:endParaRPr lang="en-US" sz="1700" dirty="0"/>
-          </a:p>
-        </p:txBody>
-      </p:sp>
-      <p:sp>
-        <p:nvSpPr>
-          <p:cNvPr id="14" name="Text 10"/>
-          <p:cNvSpPr txBox="1"/>
-          <p:nvPr/>
-        </p:nvSpPr>
-        <p:spPr>
-          <a:xfrm>
-            <a:off x="5715000" y="2057400"/>
-            <a:ext cx="2834640" cy="502920"/>
-          </a:xfrm>
-          <a:prstGeom prst="rect">
-            <a:avLst/>
-          </a:prstGeom>
-          <a:noFill/>
-          <a:ln/>
-        </p:spPr>
-        <p:txBody>
-          <a:bodyPr wrap="square" lIns="0" tIns="0" rIns="0" bIns="0" rtlCol="0" anchor="t"/>
-          <a:lstStyle/>
-          <a:p>
-            <a:pPr indent="0" marL="0">
-              <a:buNone/>
-            </a:pPr>
-            <a:r>
-              <a:rPr lang="en-US" sz="1300" dirty="0">
-                <a:solidFill>
-                  <a:srgbClr val="12261E"/>
-                </a:solidFill>
-                <a:latin typeface="Calibri" pitchFamily="34" charset="0"/>
-                <a:ea typeface="Calibri" pitchFamily="34" charset="-122"/>
-                <a:cs typeface="Calibri" pitchFamily="34" charset="-120"/>
-              </a:rPr>
-              <a:t>48 equipos y 10 columnas, paginada y editable.</a:t>
-            </a:r>
-            <a:endParaRPr lang="en-US" sz="1300" dirty="0"/>
-          </a:p>
-        </p:txBody>
-      </p:sp>
-      <p:sp>
-        <p:nvSpPr>
-          <p:cNvPr id="15" name="Text 11"/>
-          <p:cNvSpPr txBox="1"/>
-          <p:nvPr/>
-        </p:nvSpPr>
-        <p:spPr>
-          <a:xfrm>
-            <a:off x="5715000" y="2578608"/>
-            <a:ext cx="2834640" cy="274320"/>
-          </a:xfrm>
-          <a:prstGeom prst="rect">
-            <a:avLst/>
-          </a:prstGeom>
-          <a:noFill/>
-          <a:ln/>
-        </p:spPr>
-        <p:txBody>
-          <a:bodyPr wrap="square" lIns="0" tIns="0" rIns="0" bIns="0" rtlCol="0" anchor="ctr"/>
-          <a:lstStyle/>
-          <a:p>
-            <a:pPr indent="0" marL="0">
-              <a:buNone/>
-            </a:pPr>
-            <a:r>
-              <a:rPr lang="en-US" sz="1200" b="1" dirty="0">
-                <a:solidFill>
-                  <a:srgbClr val="1F7A4D"/>
-                </a:solidFill>
-                <a:latin typeface="Courier New" pitchFamily="34" charset="0"/>
-                <a:ea typeface="Courier New" pitchFamily="34" charset="-122"/>
-                <a:cs typeface="Courier New" pitchFamily="34" charset="-120"/>
-              </a:rPr>
-              <a:t>int[48][10]</a:t>
-            </a:r>
-            <a:endParaRPr lang="en-US" sz="1200" dirty="0"/>
-          </a:p>
-        </p:txBody>
-      </p:sp>
-      <p:sp>
-        <p:nvSpPr>
-          <p:cNvPr id="16" name="Shape 12"/>
-          <p:cNvSpPr/>
-          <p:nvPr/>
-        </p:nvSpPr>
-        <p:spPr>
-          <a:xfrm>
-            <a:off x="457200" y="3154680"/>
-            <a:ext cx="4023360" cy="1417320"/>
-          </a:xfrm>
-          <a:prstGeom prst="roundRect">
-            <a:avLst>
-              <a:gd name="adj" fmla="val 6452"/>
-            </a:avLst>
-          </a:prstGeom>
-          <a:solidFill>
-            <a:srgbClr val="FFFFFF"/>
-          </a:solidFill>
-          <a:ln w="12700">
-            <a:solidFill>
-              <a:srgbClr val="D5DED9"/>
-            </a:solidFill>
-            <a:prstDash val="solid"/>
-          </a:ln>
-        </p:spPr>
-      </p:sp>
-      <p:sp>
-        <p:nvSpPr>
-          <p:cNvPr id="17" name="Shape 13"/>
-          <p:cNvSpPr/>
-          <p:nvPr/>
-        </p:nvSpPr>
-        <p:spPr>
-          <a:xfrm>
-            <a:off x="685800" y="3429000"/>
-            <a:ext cx="640080" cy="640080"/>
-          </a:xfrm>
-          <a:prstGeom prst="ellipse">
-            <a:avLst/>
-          </a:prstGeom>
-          <a:solidFill>
-            <a:srgbClr val="0B3D2E"/>
-          </a:solidFill>
-          <a:ln w="12700">
-            <a:solidFill>
-              <a:srgbClr val="0B3D2E"/>
-            </a:solidFill>
-            <a:prstDash val="solid"/>
-          </a:ln>
-        </p:spPr>
-      </p:sp>
-      <p:pic>
-        <p:nvPicPr>
-          <p:cNvPr id="18" name="Image 2" descr="preencoded.png">    </p:cNvPr>
+          <p:cNvPr id="6" name="Image 0" descr="preencoded.png"/>
           <p:cNvPicPr>
             <a:picLocks noChangeAspect="1"/>
           </p:cNvPicPr>
@@ -5959,7 +5349,7 @@
         </p:blipFill>
         <p:spPr>
           <a:xfrm>
-            <a:off x="850392" y="3593592"/>
+            <a:off x="850392" y="1993392"/>
             <a:ext cx="310896" cy="310896"/>
           </a:xfrm>
           <a:prstGeom prst="rect">
@@ -5969,13 +5359,13 @@
       </p:pic>
       <p:sp>
         <p:nvSpPr>
-          <p:cNvPr id="19" name="Text 14"/>
+          <p:cNvPr id="7" name="Text 4"/>
           <p:cNvSpPr txBox="1"/>
           <p:nvPr/>
         </p:nvSpPr>
         <p:spPr>
           <a:xfrm>
-            <a:off x="1508760" y="3291840"/>
+            <a:off x="1508760" y="1691640"/>
             <a:ext cx="2834640" cy="365760"/>
           </a:xfrm>
           <a:prstGeom prst="rect">
@@ -5988,7 +5378,7 @@
           <a:bodyPr wrap="square" lIns="0" tIns="0" rIns="0" bIns="0" rtlCol="0" anchor="ctr"/>
           <a:lstStyle/>
           <a:p>
-            <a:pPr indent="0" marL="0">
+            <a:pPr marL="0" indent="0">
               <a:buNone/>
             </a:pPr>
             <a:r>
@@ -6000,7 +5390,7 @@
                 <a:ea typeface="Cambria" pitchFamily="34" charset="-122"/>
                 <a:cs typeface="Cambria" pitchFamily="34" charset="-120"/>
               </a:rPr>
-              <a:t>Fixture</a:t>
+              <a:t>Banderas</a:t>
             </a:r>
             <a:endParaRPr lang="en-US" sz="1700" dirty="0"/>
           </a:p>
@@ -6008,13 +5398,13 @@
       </p:sp>
       <p:sp>
         <p:nvSpPr>
-          <p:cNvPr id="20" name="Text 15"/>
+          <p:cNvPr id="8" name="Text 5"/>
           <p:cNvSpPr txBox="1"/>
           <p:nvPr/>
         </p:nvSpPr>
         <p:spPr>
           <a:xfrm>
-            <a:off x="1508760" y="3657600"/>
+            <a:off x="1508760" y="2057400"/>
             <a:ext cx="2834640" cy="502920"/>
           </a:xfrm>
           <a:prstGeom prst="rect">
@@ -6027,7 +5417,7 @@
           <a:bodyPr wrap="square" lIns="0" tIns="0" rIns="0" bIns="0" rtlCol="0" anchor="t"/>
           <a:lstStyle/>
           <a:p>
-            <a:pPr indent="0" marL="0">
+            <a:pPr marL="0" indent="0">
               <a:buNone/>
             </a:pPr>
             <a:r>
@@ -6039,7 +5429,7 @@
                 <a:ea typeface="Calibri" pitchFamily="34" charset="-122"/>
                 <a:cs typeface="Calibri" pitchFamily="34" charset="-120"/>
               </a:rPr>
-              <a:t>72 partidos de la fase de grupos con fecha y hora.</a:t>
+              <a:t>48 banderas en 4 tamaños, dibujadas con colores.</a:t>
             </a:r>
             <a:endParaRPr lang="en-US" sz="1300" dirty="0"/>
           </a:p>
@@ -6047,13 +5437,13 @@
       </p:sp>
       <p:sp>
         <p:nvSpPr>
-          <p:cNvPr id="21" name="Text 16"/>
+          <p:cNvPr id="9" name="Text 6"/>
           <p:cNvSpPr txBox="1"/>
           <p:nvPr/>
         </p:nvSpPr>
         <p:spPr>
           <a:xfrm>
-            <a:off x="1508760" y="4178808"/>
+            <a:off x="1508760" y="2578608"/>
             <a:ext cx="2834640" cy="274320"/>
           </a:xfrm>
           <a:prstGeom prst="rect">
@@ -6066,7 +5456,7 @@
           <a:bodyPr wrap="square" lIns="0" tIns="0" rIns="0" bIns="0" rtlCol="0" anchor="ctr"/>
           <a:lstStyle/>
           <a:p>
-            <a:pPr indent="0" marL="0">
+            <a:pPr marL="0" indent="0">
               <a:buNone/>
             </a:pPr>
             <a:r>
@@ -6078,7 +5468,7 @@
                 <a:ea typeface="Courier New" pitchFamily="34" charset="-122"/>
                 <a:cs typeface="Courier New" pitchFamily="34" charset="-120"/>
               </a:rPr>
-              <a:t>String[72][8]</a:t>
+              <a:t>char[480][15]</a:t>
             </a:r>
             <a:endParaRPr lang="en-US" sz="1200" dirty="0"/>
           </a:p>
@@ -6086,13 +5476,13 @@
       </p:sp>
       <p:sp>
         <p:nvSpPr>
-          <p:cNvPr id="22" name="Shape 17"/>
-          <p:cNvSpPr/>
-          <p:nvPr/>
-        </p:nvSpPr>
-        <p:spPr>
-          <a:xfrm>
-            <a:off x="4663440" y="3154680"/>
+          <p:cNvPr id="10" name="Shape 7"/>
+          <p:cNvSpPr/>
+          <p:nvPr/>
+        </p:nvSpPr>
+        <p:spPr>
+          <a:xfrm>
+            <a:off x="4663440" y="1554480"/>
             <a:ext cx="4023360" cy="1417320"/>
           </a:xfrm>
           <a:prstGeom prst="roundRect">
@@ -6113,13 +5503,13 @@
       </p:sp>
       <p:sp>
         <p:nvSpPr>
-          <p:cNvPr id="23" name="Shape 18"/>
-          <p:cNvSpPr/>
-          <p:nvPr/>
-        </p:nvSpPr>
-        <p:spPr>
-          <a:xfrm>
-            <a:off x="4892040" y="3429000"/>
+          <p:cNvPr id="11" name="Shape 8"/>
+          <p:cNvSpPr/>
+          <p:nvPr/>
+        </p:nvSpPr>
+        <p:spPr>
+          <a:xfrm>
+            <a:off x="4892040" y="1828800"/>
             <a:ext cx="640080" cy="640080"/>
           </a:xfrm>
           <a:prstGeom prst="ellipse">
@@ -6138,7 +5528,7 @@
       </p:sp>
       <p:pic>
         <p:nvPicPr>
-          <p:cNvPr id="24" name="Image 3" descr="preencoded.png">    </p:cNvPr>
+          <p:cNvPr id="12" name="Image 1" descr="preencoded.png"/>
           <p:cNvPicPr>
             <a:picLocks noChangeAspect="1"/>
           </p:cNvPicPr>
@@ -6152,7 +5542,7 @@
         </p:blipFill>
         <p:spPr>
           <a:xfrm>
-            <a:off x="5056632" y="3593592"/>
+            <a:off x="5056632" y="1993392"/>
             <a:ext cx="310896" cy="310896"/>
           </a:xfrm>
           <a:prstGeom prst="rect">
@@ -6162,13 +5552,13 @@
       </p:pic>
       <p:sp>
         <p:nvSpPr>
-          <p:cNvPr id="25" name="Text 19"/>
+          <p:cNvPr id="13" name="Text 9"/>
           <p:cNvSpPr txBox="1"/>
           <p:nvPr/>
         </p:nvSpPr>
         <p:spPr>
           <a:xfrm>
-            <a:off x="5715000" y="3291840"/>
+            <a:off x="5715000" y="1691640"/>
             <a:ext cx="2834640" cy="365760"/>
           </a:xfrm>
           <a:prstGeom prst="rect">
@@ -6181,7 +5571,7 @@
           <a:bodyPr wrap="square" lIns="0" tIns="0" rIns="0" bIns="0" rtlCol="0" anchor="ctr"/>
           <a:lstStyle/>
           <a:p>
-            <a:pPr indent="0" marL="0">
+            <a:pPr marL="0" indent="0">
               <a:buNone/>
             </a:pPr>
             <a:r>
@@ -6193,7 +5583,7 @@
                 <a:ea typeface="Cambria" pitchFamily="34" charset="-122"/>
                 <a:cs typeface="Cambria" pitchFamily="34" charset="-120"/>
               </a:rPr>
-              <a:t>Información de países</a:t>
+              <a:t>Tabla de posiciones</a:t>
             </a:r>
             <a:endParaRPr lang="en-US" sz="1700" dirty="0"/>
           </a:p>
@@ -6201,13 +5591,13 @@
       </p:sp>
       <p:sp>
         <p:nvSpPr>
-          <p:cNvPr id="26" name="Text 20"/>
+          <p:cNvPr id="14" name="Text 10"/>
           <p:cNvSpPr txBox="1"/>
           <p:nvPr/>
         </p:nvSpPr>
         <p:spPr>
           <a:xfrm>
-            <a:off x="5715000" y="3657600"/>
+            <a:off x="5715000" y="2057400"/>
             <a:ext cx="2834640" cy="502920"/>
           </a:xfrm>
           <a:prstGeom prst="rect">
@@ -6220,7 +5610,7 @@
           <a:bodyPr wrap="square" lIns="0" tIns="0" rIns="0" bIns="0" rtlCol="0" anchor="t"/>
           <a:lstStyle/>
           <a:p>
-            <a:pPr indent="0" marL="0">
+            <a:pPr marL="0" indent="0">
               <a:buNone/>
             </a:pPr>
             <a:r>
@@ -6232,7 +5622,7 @@
                 <a:ea typeface="Calibri" pitchFamily="34" charset="-122"/>
                 <a:cs typeface="Calibri" pitchFamily="34" charset="-120"/>
               </a:rPr>
-              <a:t>Capital, apariciones en mundiales y once titular.</a:t>
+              <a:t>48 equipos y 10 columnas, paginada y editable.</a:t>
             </a:r>
             <a:endParaRPr lang="en-US" sz="1300" dirty="0"/>
           </a:p>
@@ -6240,13 +5630,13 @@
       </p:sp>
       <p:sp>
         <p:nvSpPr>
-          <p:cNvPr id="27" name="Text 21"/>
+          <p:cNvPr id="15" name="Text 11"/>
           <p:cNvSpPr txBox="1"/>
           <p:nvPr/>
         </p:nvSpPr>
         <p:spPr>
           <a:xfrm>
-            <a:off x="5715000" y="4178808"/>
+            <a:off x="5715000" y="2578608"/>
             <a:ext cx="2834640" cy="274320"/>
           </a:xfrm>
           <a:prstGeom prst="rect">
@@ -6259,7 +5649,393 @@
           <a:bodyPr wrap="square" lIns="0" tIns="0" rIns="0" bIns="0" rtlCol="0" anchor="ctr"/>
           <a:lstStyle/>
           <a:p>
-            <a:pPr indent="0" marL="0">
+            <a:pPr marL="0" indent="0">
+              <a:buNone/>
+            </a:pPr>
+            <a:r>
+              <a:rPr lang="en-US" sz="1200" b="1" dirty="0">
+                <a:solidFill>
+                  <a:srgbClr val="1F7A4D"/>
+                </a:solidFill>
+                <a:latin typeface="Courier New" pitchFamily="34" charset="0"/>
+                <a:ea typeface="Courier New" pitchFamily="34" charset="-122"/>
+                <a:cs typeface="Courier New" pitchFamily="34" charset="-120"/>
+              </a:rPr>
+              <a:t>int[48][10]</a:t>
+            </a:r>
+            <a:endParaRPr lang="en-US" sz="1200" dirty="0"/>
+          </a:p>
+        </p:txBody>
+      </p:sp>
+      <p:sp>
+        <p:nvSpPr>
+          <p:cNvPr id="16" name="Shape 12"/>
+          <p:cNvSpPr/>
+          <p:nvPr/>
+        </p:nvSpPr>
+        <p:spPr>
+          <a:xfrm>
+            <a:off x="457200" y="3154680"/>
+            <a:ext cx="4023360" cy="1417320"/>
+          </a:xfrm>
+          <a:prstGeom prst="roundRect">
+            <a:avLst>
+              <a:gd name="adj" fmla="val 6452"/>
+            </a:avLst>
+          </a:prstGeom>
+          <a:solidFill>
+            <a:srgbClr val="FFFFFF"/>
+          </a:solidFill>
+          <a:ln w="12700">
+            <a:solidFill>
+              <a:srgbClr val="D5DED9"/>
+            </a:solidFill>
+            <a:prstDash val="solid"/>
+          </a:ln>
+        </p:spPr>
+      </p:sp>
+      <p:sp>
+        <p:nvSpPr>
+          <p:cNvPr id="17" name="Shape 13"/>
+          <p:cNvSpPr/>
+          <p:nvPr/>
+        </p:nvSpPr>
+        <p:spPr>
+          <a:xfrm>
+            <a:off x="685800" y="3429000"/>
+            <a:ext cx="640080" cy="640080"/>
+          </a:xfrm>
+          <a:prstGeom prst="ellipse">
+            <a:avLst/>
+          </a:prstGeom>
+          <a:solidFill>
+            <a:srgbClr val="0B3D2E"/>
+          </a:solidFill>
+          <a:ln w="12700">
+            <a:solidFill>
+              <a:srgbClr val="0B3D2E"/>
+            </a:solidFill>
+            <a:prstDash val="solid"/>
+          </a:ln>
+        </p:spPr>
+      </p:sp>
+      <p:pic>
+        <p:nvPicPr>
+          <p:cNvPr id="18" name="Image 2" descr="preencoded.png"/>
+          <p:cNvPicPr>
+            <a:picLocks noChangeAspect="1"/>
+          </p:cNvPicPr>
+          <p:nvPr/>
+        </p:nvPicPr>
+        <p:blipFill>
+          <a:blip r:embed="rId5"/>
+          <a:stretch>
+            <a:fillRect/>
+          </a:stretch>
+        </p:blipFill>
+        <p:spPr>
+          <a:xfrm>
+            <a:off x="850392" y="3593592"/>
+            <a:ext cx="310896" cy="310896"/>
+          </a:xfrm>
+          <a:prstGeom prst="rect">
+            <a:avLst/>
+          </a:prstGeom>
+        </p:spPr>
+      </p:pic>
+      <p:sp>
+        <p:nvSpPr>
+          <p:cNvPr id="19" name="Text 14"/>
+          <p:cNvSpPr txBox="1"/>
+          <p:nvPr/>
+        </p:nvSpPr>
+        <p:spPr>
+          <a:xfrm>
+            <a:off x="1508760" y="3291840"/>
+            <a:ext cx="2834640" cy="365760"/>
+          </a:xfrm>
+          <a:prstGeom prst="rect">
+            <a:avLst/>
+          </a:prstGeom>
+          <a:noFill/>
+          <a:ln/>
+        </p:spPr>
+        <p:txBody>
+          <a:bodyPr wrap="square" lIns="0" tIns="0" rIns="0" bIns="0" rtlCol="0" anchor="ctr"/>
+          <a:lstStyle/>
+          <a:p>
+            <a:pPr marL="0" indent="0">
+              <a:buNone/>
+            </a:pPr>
+            <a:r>
+              <a:rPr lang="en-US" sz="1700" b="1" dirty="0">
+                <a:solidFill>
+                  <a:srgbClr val="0B3D2E"/>
+                </a:solidFill>
+                <a:latin typeface="Cambria" pitchFamily="34" charset="0"/>
+                <a:ea typeface="Cambria" pitchFamily="34" charset="-122"/>
+                <a:cs typeface="Cambria" pitchFamily="34" charset="-120"/>
+              </a:rPr>
+              <a:t>Fixture</a:t>
+            </a:r>
+            <a:endParaRPr lang="en-US" sz="1700" dirty="0"/>
+          </a:p>
+        </p:txBody>
+      </p:sp>
+      <p:sp>
+        <p:nvSpPr>
+          <p:cNvPr id="20" name="Text 15"/>
+          <p:cNvSpPr txBox="1"/>
+          <p:nvPr/>
+        </p:nvSpPr>
+        <p:spPr>
+          <a:xfrm>
+            <a:off x="1508760" y="3657600"/>
+            <a:ext cx="2834640" cy="502920"/>
+          </a:xfrm>
+          <a:prstGeom prst="rect">
+            <a:avLst/>
+          </a:prstGeom>
+          <a:noFill/>
+          <a:ln/>
+        </p:spPr>
+        <p:txBody>
+          <a:bodyPr wrap="square" lIns="0" tIns="0" rIns="0" bIns="0" rtlCol="0" anchor="t"/>
+          <a:lstStyle/>
+          <a:p>
+            <a:pPr marL="0" indent="0">
+              <a:buNone/>
+            </a:pPr>
+            <a:r>
+              <a:rPr lang="en-US" sz="1300" dirty="0">
+                <a:solidFill>
+                  <a:srgbClr val="12261E"/>
+                </a:solidFill>
+                <a:latin typeface="Calibri" pitchFamily="34" charset="0"/>
+                <a:ea typeface="Calibri" pitchFamily="34" charset="-122"/>
+                <a:cs typeface="Calibri" pitchFamily="34" charset="-120"/>
+              </a:rPr>
+              <a:t>72 partidos de la fase de grupos con fecha y hora.</a:t>
+            </a:r>
+            <a:endParaRPr lang="en-US" sz="1300" dirty="0"/>
+          </a:p>
+        </p:txBody>
+      </p:sp>
+      <p:sp>
+        <p:nvSpPr>
+          <p:cNvPr id="21" name="Text 16"/>
+          <p:cNvSpPr txBox="1"/>
+          <p:nvPr/>
+        </p:nvSpPr>
+        <p:spPr>
+          <a:xfrm>
+            <a:off x="1508760" y="4178808"/>
+            <a:ext cx="2834640" cy="274320"/>
+          </a:xfrm>
+          <a:prstGeom prst="rect">
+            <a:avLst/>
+          </a:prstGeom>
+          <a:noFill/>
+          <a:ln/>
+        </p:spPr>
+        <p:txBody>
+          <a:bodyPr wrap="square" lIns="0" tIns="0" rIns="0" bIns="0" rtlCol="0" anchor="ctr"/>
+          <a:lstStyle/>
+          <a:p>
+            <a:pPr marL="0" indent="0">
+              <a:buNone/>
+            </a:pPr>
+            <a:r>
+              <a:rPr lang="en-US" sz="1200" b="1" dirty="0">
+                <a:solidFill>
+                  <a:srgbClr val="1F7A4D"/>
+                </a:solidFill>
+                <a:latin typeface="Courier New" pitchFamily="34" charset="0"/>
+                <a:ea typeface="Courier New" pitchFamily="34" charset="-122"/>
+                <a:cs typeface="Courier New" pitchFamily="34" charset="-120"/>
+              </a:rPr>
+              <a:t>String[72][8]</a:t>
+            </a:r>
+            <a:endParaRPr lang="en-US" sz="1200" dirty="0"/>
+          </a:p>
+        </p:txBody>
+      </p:sp>
+      <p:sp>
+        <p:nvSpPr>
+          <p:cNvPr id="22" name="Shape 17"/>
+          <p:cNvSpPr/>
+          <p:nvPr/>
+        </p:nvSpPr>
+        <p:spPr>
+          <a:xfrm>
+            <a:off x="4663440" y="3154680"/>
+            <a:ext cx="4023360" cy="1417320"/>
+          </a:xfrm>
+          <a:prstGeom prst="roundRect">
+            <a:avLst>
+              <a:gd name="adj" fmla="val 6452"/>
+            </a:avLst>
+          </a:prstGeom>
+          <a:solidFill>
+            <a:srgbClr val="FFFFFF"/>
+          </a:solidFill>
+          <a:ln w="12700">
+            <a:solidFill>
+              <a:srgbClr val="D5DED9"/>
+            </a:solidFill>
+            <a:prstDash val="solid"/>
+          </a:ln>
+        </p:spPr>
+      </p:sp>
+      <p:sp>
+        <p:nvSpPr>
+          <p:cNvPr id="23" name="Shape 18"/>
+          <p:cNvSpPr/>
+          <p:nvPr/>
+        </p:nvSpPr>
+        <p:spPr>
+          <a:xfrm>
+            <a:off x="4892040" y="3429000"/>
+            <a:ext cx="640080" cy="640080"/>
+          </a:xfrm>
+          <a:prstGeom prst="ellipse">
+            <a:avLst/>
+          </a:prstGeom>
+          <a:solidFill>
+            <a:srgbClr val="0B3D2E"/>
+          </a:solidFill>
+          <a:ln w="12700">
+            <a:solidFill>
+              <a:srgbClr val="0B3D2E"/>
+            </a:solidFill>
+            <a:prstDash val="solid"/>
+          </a:ln>
+        </p:spPr>
+      </p:sp>
+      <p:pic>
+        <p:nvPicPr>
+          <p:cNvPr id="24" name="Image 3" descr="preencoded.png"/>
+          <p:cNvPicPr>
+            <a:picLocks noChangeAspect="1"/>
+          </p:cNvPicPr>
+          <p:nvPr/>
+        </p:nvPicPr>
+        <p:blipFill>
+          <a:blip r:embed="rId6"/>
+          <a:stretch>
+            <a:fillRect/>
+          </a:stretch>
+        </p:blipFill>
+        <p:spPr>
+          <a:xfrm>
+            <a:off x="5056632" y="3593592"/>
+            <a:ext cx="310896" cy="310896"/>
+          </a:xfrm>
+          <a:prstGeom prst="rect">
+            <a:avLst/>
+          </a:prstGeom>
+        </p:spPr>
+      </p:pic>
+      <p:sp>
+        <p:nvSpPr>
+          <p:cNvPr id="25" name="Text 19"/>
+          <p:cNvSpPr txBox="1"/>
+          <p:nvPr/>
+        </p:nvSpPr>
+        <p:spPr>
+          <a:xfrm>
+            <a:off x="5715000" y="3291840"/>
+            <a:ext cx="2834640" cy="365760"/>
+          </a:xfrm>
+          <a:prstGeom prst="rect">
+            <a:avLst/>
+          </a:prstGeom>
+          <a:noFill/>
+          <a:ln/>
+        </p:spPr>
+        <p:txBody>
+          <a:bodyPr wrap="square" lIns="0" tIns="0" rIns="0" bIns="0" rtlCol="0" anchor="ctr"/>
+          <a:lstStyle/>
+          <a:p>
+            <a:pPr marL="0" indent="0">
+              <a:buNone/>
+            </a:pPr>
+            <a:r>
+              <a:rPr lang="en-US" sz="1700" b="1" dirty="0">
+                <a:solidFill>
+                  <a:srgbClr val="0B3D2E"/>
+                </a:solidFill>
+                <a:latin typeface="Cambria" pitchFamily="34" charset="0"/>
+                <a:ea typeface="Cambria" pitchFamily="34" charset="-122"/>
+                <a:cs typeface="Cambria" pitchFamily="34" charset="-120"/>
+              </a:rPr>
+              <a:t>Información de países</a:t>
+            </a:r>
+            <a:endParaRPr lang="en-US" sz="1700" dirty="0"/>
+          </a:p>
+        </p:txBody>
+      </p:sp>
+      <p:sp>
+        <p:nvSpPr>
+          <p:cNvPr id="26" name="Text 20"/>
+          <p:cNvSpPr txBox="1"/>
+          <p:nvPr/>
+        </p:nvSpPr>
+        <p:spPr>
+          <a:xfrm>
+            <a:off x="5715000" y="3657600"/>
+            <a:ext cx="2834640" cy="502920"/>
+          </a:xfrm>
+          <a:prstGeom prst="rect">
+            <a:avLst/>
+          </a:prstGeom>
+          <a:noFill/>
+          <a:ln/>
+        </p:spPr>
+        <p:txBody>
+          <a:bodyPr wrap="square" lIns="0" tIns="0" rIns="0" bIns="0" rtlCol="0" anchor="t"/>
+          <a:lstStyle/>
+          <a:p>
+            <a:pPr marL="0" indent="0">
+              <a:buNone/>
+            </a:pPr>
+            <a:r>
+              <a:rPr lang="en-US" sz="1300" dirty="0">
+                <a:solidFill>
+                  <a:srgbClr val="12261E"/>
+                </a:solidFill>
+                <a:latin typeface="Calibri" pitchFamily="34" charset="0"/>
+                <a:ea typeface="Calibri" pitchFamily="34" charset="-122"/>
+                <a:cs typeface="Calibri" pitchFamily="34" charset="-120"/>
+              </a:rPr>
+              <a:t>Capital, apariciones en mundiales y once titular.</a:t>
+            </a:r>
+            <a:endParaRPr lang="en-US" sz="1300" dirty="0"/>
+          </a:p>
+        </p:txBody>
+      </p:sp>
+      <p:sp>
+        <p:nvSpPr>
+          <p:cNvPr id="27" name="Text 21"/>
+          <p:cNvSpPr txBox="1"/>
+          <p:nvPr/>
+        </p:nvSpPr>
+        <p:spPr>
+          <a:xfrm>
+            <a:off x="5715000" y="4178808"/>
+            <a:ext cx="2834640" cy="274320"/>
+          </a:xfrm>
+          <a:prstGeom prst="rect">
+            <a:avLst/>
+          </a:prstGeom>
+          <a:noFill/>
+          <a:ln/>
+        </p:spPr>
+        <p:txBody>
+          <a:bodyPr wrap="square" lIns="0" tIns="0" rIns="0" bIns="0" rtlCol="0" anchor="ctr"/>
+          <a:lstStyle/>
+          <a:p>
+            <a:pPr marL="0" indent="0">
               <a:buNone/>
             </a:pPr>
             <a:r>
@@ -6293,6 +6069,7 @@
         <a:solidFill>
           <a:srgbClr val="F2F5F3"/>
         </a:solidFill>
+        <a:effectLst/>
       </p:bgPr>
     </p:bg>
     <p:spTree>
@@ -6330,7 +6107,7 @@
           <a:bodyPr wrap="square" lIns="0" tIns="0" rIns="0" bIns="0" rtlCol="0" anchor="ctr"/>
           <a:lstStyle/>
           <a:p>
-            <a:pPr indent="0" marL="0">
+            <a:pPr marL="0" indent="0">
               <a:buNone/>
             </a:pPr>
             <a:r>
@@ -6350,14 +6127,14 @@
       </p:sp>
       <p:pic>
         <p:nvPicPr>
-          <p:cNvPr id="3" name="Image 0" descr="img/bandera.png">    </p:cNvPr>
+          <p:cNvPr id="3" name="Image 0" descr="img/bandera.png"/>
           <p:cNvPicPr>
             <a:picLocks noChangeAspect="1"/>
           </p:cNvPicPr>
           <p:nvPr/>
         </p:nvPicPr>
         <p:blipFill>
-          <a:blip r:embed="rId1"/>
+          <a:blip r:embed="rId3"/>
           <a:stretch>
             <a:fillRect/>
           </a:stretch>
@@ -6371,7 +6148,7 @@
             <a:avLst/>
           </a:prstGeom>
           <a:effectLst>
-            <a:outerShdw sx="100000" sy="100000" kx="0" ky="0" algn="bl" rotWithShape="0" blurRad="76200" dist="25400" dir="5400000">
+            <a:outerShdw blurRad="76200" dist="25400" dir="5400000" algn="bl" rotWithShape="0">
               <a:srgbClr val="000000">
                 <a:alpha val="25000"/>
               </a:srgbClr>
@@ -6400,7 +6177,7 @@
           <a:bodyPr wrap="square" lIns="0" tIns="0" rIns="0" bIns="0" rtlCol="0" anchor="ctr"/>
           <a:lstStyle/>
           <a:p>
-            <a:pPr indent="0" marL="0">
+            <a:pPr marL="0" indent="0">
               <a:buNone/>
             </a:pPr>
             <a:r>
@@ -6551,7 +6328,7 @@
           <a:bodyPr wrap="square" lIns="50800" tIns="50800" rIns="50800" bIns="50800" rtlCol="0" anchor="ctr"/>
           <a:lstStyle/>
           <a:p>
-            <a:pPr indent="0" marL="0">
+            <a:pPr marL="0" indent="0">
               <a:buNone/>
             </a:pPr>
             <a:r>
@@ -6568,13 +6345,13 @@
             <a:endParaRPr lang="en-US" sz="1100" dirty="0"/>
           </a:p>
           <a:p>
-            <a:pPr indent="0" marL="0">
+            <a:pPr marL="0" indent="0">
               <a:buNone/>
             </a:pPr>
             <a:endParaRPr lang="en-US" sz="1100" dirty="0"/>
           </a:p>
           <a:p>
-            <a:pPr indent="0" marL="0">
+            <a:pPr marL="0" indent="0">
               <a:buNone/>
             </a:pPr>
             <a:r>
@@ -6591,7 +6368,7 @@
             <a:endParaRPr lang="en-US" sz="1100" dirty="0"/>
           </a:p>
           <a:p>
-            <a:pPr indent="0" marL="0">
+            <a:pPr marL="0" indent="0">
               <a:buNone/>
             </a:pPr>
             <a:r>
@@ -6608,7 +6385,7 @@
             <a:endParaRPr lang="en-US" sz="1100" dirty="0"/>
           </a:p>
           <a:p>
-            <a:pPr indent="0" marL="0">
+            <a:pPr marL="0" indent="0">
               <a:buNone/>
             </a:pPr>
             <a:r>
@@ -6625,13 +6402,13 @@
             <a:endParaRPr lang="en-US" sz="1100" dirty="0"/>
           </a:p>
           <a:p>
-            <a:pPr indent="0" marL="0">
+            <a:pPr marL="0" indent="0">
               <a:buNone/>
             </a:pPr>
             <a:endParaRPr lang="en-US" sz="1100" dirty="0"/>
           </a:p>
           <a:p>
-            <a:pPr indent="0" marL="0">
+            <a:pPr marL="0" indent="0">
               <a:buNone/>
             </a:pPr>
             <a:r>
@@ -6648,7 +6425,7 @@
             <a:endParaRPr lang="en-US" sz="1100" dirty="0"/>
           </a:p>
           <a:p>
-            <a:pPr indent="0" marL="0">
+            <a:pPr marL="0" indent="0">
               <a:buNone/>
             </a:pPr>
             <a:r>
@@ -6665,7 +6442,7 @@
             <a:endParaRPr lang="en-US" sz="1100" dirty="0"/>
           </a:p>
           <a:p>
-            <a:pPr indent="0" marL="0">
+            <a:pPr marL="0" indent="0">
               <a:buNone/>
             </a:pPr>
             <a:r>
@@ -6699,6 +6476,7 @@
         <a:solidFill>
           <a:srgbClr val="F2F5F3"/>
         </a:solidFill>
+        <a:effectLst/>
       </p:bgPr>
     </p:bg>
     <p:spTree>
@@ -6736,7 +6514,7 @@
           <a:bodyPr wrap="square" lIns="0" tIns="0" rIns="0" bIns="0" rtlCol="0" anchor="ctr"/>
           <a:lstStyle/>
           <a:p>
-            <a:pPr indent="0" marL="0">
+            <a:pPr marL="0" indent="0">
               <a:buNone/>
             </a:pPr>
             <a:r>
@@ -6756,14 +6534,14 @@
       </p:sp>
       <p:pic>
         <p:nvPicPr>
-          <p:cNvPr id="3" name="Image 0" descr="img/tabla.png">    </p:cNvPr>
+          <p:cNvPr id="3" name="Image 0" descr="img/tabla.png"/>
           <p:cNvPicPr>
             <a:picLocks noChangeAspect="1"/>
           </p:cNvPicPr>
           <p:nvPr/>
         </p:nvPicPr>
         <p:blipFill>
-          <a:blip r:embed="rId1"/>
+          <a:blip r:embed="rId3"/>
           <a:stretch>
             <a:fillRect/>
           </a:stretch>
@@ -6777,7 +6555,7 @@
             <a:avLst/>
           </a:prstGeom>
           <a:effectLst>
-            <a:outerShdw sx="100000" sy="100000" kx="0" ky="0" algn="bl" rotWithShape="0" blurRad="76200" dist="25400" dir="5400000">
+            <a:outerShdw blurRad="76200" dist="25400" dir="5400000" algn="bl" rotWithShape="0">
               <a:srgbClr val="000000">
                 <a:alpha val="25000"/>
               </a:srgbClr>
@@ -6833,7 +6611,7 @@
           <a:bodyPr wrap="square" lIns="50800" tIns="50800" rIns="50800" bIns="50800" rtlCol="0" anchor="ctr"/>
           <a:lstStyle/>
           <a:p>
-            <a:pPr indent="0" marL="0">
+            <a:pPr marL="0" indent="0">
               <a:buNone/>
             </a:pPr>
             <a:r>
@@ -6850,13 +6628,13 @@
             <a:endParaRPr lang="en-US" sz="1050" dirty="0"/>
           </a:p>
           <a:p>
-            <a:pPr indent="0" marL="0">
+            <a:pPr marL="0" indent="0">
               <a:buNone/>
             </a:pPr>
             <a:endParaRPr lang="en-US" sz="1050" dirty="0"/>
           </a:p>
           <a:p>
-            <a:pPr indent="0" marL="0">
+            <a:pPr marL="0" indent="0">
               <a:buNone/>
             </a:pPr>
             <a:r>
@@ -6873,7 +6651,7 @@
             <a:endParaRPr lang="en-US" sz="1050" dirty="0"/>
           </a:p>
           <a:p>
-            <a:pPr indent="0" marL="0">
+            <a:pPr marL="0" indent="0">
               <a:buNone/>
             </a:pPr>
             <a:r>
@@ -6890,7 +6668,7 @@
             <a:endParaRPr lang="en-US" sz="1050" dirty="0"/>
           </a:p>
           <a:p>
-            <a:pPr indent="0" marL="0">
+            <a:pPr marL="0" indent="0">
               <a:buNone/>
             </a:pPr>
             <a:r>
@@ -6907,7 +6685,7 @@
             <a:endParaRPr lang="en-US" sz="1050" dirty="0"/>
           </a:p>
           <a:p>
-            <a:pPr indent="0" marL="0">
+            <a:pPr marL="0" indent="0">
               <a:buNone/>
             </a:pPr>
             <a:r>
@@ -6924,7 +6702,7 @@
             <a:endParaRPr lang="en-US" sz="1050" dirty="0"/>
           </a:p>
           <a:p>
-            <a:pPr indent="0" marL="0">
+            <a:pPr marL="0" indent="0">
               <a:buNone/>
             </a:pPr>
             <a:r>
@@ -6941,7 +6719,7 @@
             <a:endParaRPr lang="en-US" sz="1050" dirty="0"/>
           </a:p>
           <a:p>
-            <a:pPr indent="0" marL="0">
+            <a:pPr marL="0" indent="0">
               <a:buNone/>
             </a:pPr>
             <a:r>
@@ -6958,7 +6736,7 @@
             <a:endParaRPr lang="en-US" sz="1050" dirty="0"/>
           </a:p>
           <a:p>
-            <a:pPr indent="0" marL="0">
+            <a:pPr marL="0" indent="0">
               <a:buNone/>
             </a:pPr>
             <a:r>
@@ -6997,7 +6775,7 @@
           <a:bodyPr wrap="square" lIns="0" tIns="0" rIns="0" bIns="0" rtlCol="0" anchor="ctr"/>
           <a:lstStyle/>
           <a:p>
-            <a:pPr indent="0" marL="0">
+            <a:pPr marL="0" indent="0">
               <a:buNone/>
             </a:pPr>
             <a:r>
@@ -7137,6 +6915,7 @@
         <a:solidFill>
           <a:srgbClr val="F2F5F3"/>
         </a:solidFill>
+        <a:effectLst/>
       </p:bgPr>
     </p:bg>
     <p:spTree>
@@ -7174,7 +6953,7 @@
           <a:bodyPr wrap="square" lIns="0" tIns="0" rIns="0" bIns="0" rtlCol="0" anchor="ctr"/>
           <a:lstStyle/>
           <a:p>
-            <a:pPr indent="0" marL="0">
+            <a:pPr marL="0" indent="0">
               <a:buNone/>
             </a:pPr>
             <a:r>
@@ -7194,14 +6973,14 @@
       </p:sp>
       <p:pic>
         <p:nvPicPr>
-          <p:cNvPr id="3" name="Image 0" descr="img/fixture.png">    </p:cNvPr>
+          <p:cNvPr id="3" name="Image 0" descr="img/fixture.png"/>
           <p:cNvPicPr>
             <a:picLocks noChangeAspect="1"/>
           </p:cNvPicPr>
           <p:nvPr/>
         </p:nvPicPr>
         <p:blipFill>
-          <a:blip r:embed="rId1"/>
+          <a:blip r:embed="rId3"/>
           <a:stretch>
             <a:fillRect/>
           </a:stretch>
@@ -7215,7 +6994,7 @@
             <a:avLst/>
           </a:prstGeom>
           <a:effectLst>
-            <a:outerShdw sx="100000" sy="100000" kx="0" ky="0" algn="bl" rotWithShape="0" blurRad="76200" dist="25400" dir="5400000">
+            <a:outerShdw blurRad="76200" dist="25400" dir="5400000" algn="bl" rotWithShape="0">
               <a:srgbClr val="000000">
                 <a:alpha val="25000"/>
               </a:srgbClr>
@@ -7271,7 +7050,7 @@
           <a:bodyPr wrap="square" lIns="50800" tIns="50800" rIns="50800" bIns="50800" rtlCol="0" anchor="ctr"/>
           <a:lstStyle/>
           <a:p>
-            <a:pPr indent="0" marL="0">
+            <a:pPr marL="0" indent="0">
               <a:buNone/>
             </a:pPr>
             <a:r>
@@ -7288,7 +7067,7 @@
             <a:endParaRPr lang="en-US" sz="900" dirty="0"/>
           </a:p>
           <a:p>
-            <a:pPr indent="0" marL="0">
+            <a:pPr marL="0" indent="0">
               <a:buNone/>
             </a:pPr>
             <a:r>
@@ -7305,7 +7084,7 @@
             <a:endParaRPr lang="en-US" sz="900" dirty="0"/>
           </a:p>
           <a:p>
-            <a:pPr indent="0" marL="0">
+            <a:pPr marL="0" indent="0">
               <a:buNone/>
             </a:pPr>
             <a:r>
@@ -7322,7 +7101,7 @@
             <a:endParaRPr lang="en-US" sz="900" dirty="0"/>
           </a:p>
           <a:p>
-            <a:pPr indent="0" marL="0">
+            <a:pPr marL="0" indent="0">
               <a:buNone/>
             </a:pPr>
             <a:r>
@@ -7336,9 +7115,6 @@
               </a:rPr>
               <a:t>  ...   </a:t>
             </a:r>
-            <a:pPr indent="0" marL="0">
-              <a:buNone/>
-            </a:pPr>
             <a:r>
               <a:rPr lang="en-US" sz="900" dirty="0">
                 <a:solidFill>
@@ -7353,7 +7129,7 @@
             <a:endParaRPr lang="en-US" sz="900" dirty="0"/>
           </a:p>
           <a:p>
-            <a:pPr indent="0" marL="0">
+            <a:pPr marL="0" indent="0">
               <a:buNone/>
             </a:pPr>
             <a:r>
@@ -7370,7 +7146,7 @@
             <a:endParaRPr lang="en-US" sz="900" dirty="0"/>
           </a:p>
           <a:p>
-            <a:pPr indent="0" marL="0">
+            <a:pPr marL="0" indent="0">
               <a:buNone/>
             </a:pPr>
             <a:r>
@@ -7387,7 +7163,7 @@
             <a:endParaRPr lang="en-US" sz="900" dirty="0"/>
           </a:p>
           <a:p>
-            <a:pPr indent="0" marL="0">
+            <a:pPr marL="0" indent="0">
               <a:buNone/>
             </a:pPr>
             <a:r>
@@ -7404,7 +7180,7 @@
             <a:endParaRPr lang="en-US" sz="900" dirty="0"/>
           </a:p>
           <a:p>
-            <a:pPr indent="0" marL="0">
+            <a:pPr marL="0" indent="0">
               <a:buNone/>
             </a:pPr>
             <a:r>
@@ -7544,6 +7320,7 @@
         <a:solidFill>
           <a:srgbClr val="0B3D2E"/>
         </a:solidFill>
+        <a:effectLst/>
       </p:bgPr>
     </p:bg>
     <p:spTree>
@@ -7581,7 +7358,7 @@
           <a:bodyPr wrap="square" lIns="0" tIns="0" rIns="0" bIns="0" rtlCol="0" anchor="ctr"/>
           <a:lstStyle/>
           <a:p>
-            <a:pPr indent="0" marL="0">
+            <a:pPr marL="0" indent="0">
               <a:buNone/>
             </a:pPr>
             <a:r>
@@ -7607,7 +7384,7 @@
         </p:nvSpPr>
         <p:spPr>
           <a:xfrm>
-            <a:off x="457200" y="1188720"/>
+            <a:off x="1731818" y="1188720"/>
             <a:ext cx="4023360" cy="2834640"/>
           </a:xfrm>
           <a:prstGeom prst="roundRect">
@@ -7634,7 +7411,7 @@
         </p:nvSpPr>
         <p:spPr>
           <a:xfrm>
-            <a:off x="685800" y="1325880"/>
+            <a:off x="1842655" y="1325880"/>
             <a:ext cx="3566160" cy="365760"/>
           </a:xfrm>
           <a:prstGeom prst="rect">
@@ -7647,7 +7424,7 @@
           <a:bodyPr wrap="square" lIns="0" tIns="0" rIns="0" bIns="0" rtlCol="0" anchor="ctr"/>
           <a:lstStyle/>
           <a:p>
-            <a:pPr indent="0" marL="0">
+            <a:pPr marL="0" indent="0">
               <a:buNone/>
             </a:pPr>
             <a:r>
@@ -7673,7 +7450,7 @@
         </p:nvSpPr>
         <p:spPr>
           <a:xfrm>
-            <a:off x="685800" y="1783080"/>
+            <a:off x="1842655" y="1828800"/>
             <a:ext cx="3566160" cy="2560320"/>
           </a:xfrm>
           <a:prstGeom prst="rect">
@@ -7773,41 +7550,14 @@
       </p:sp>
       <p:sp>
         <p:nvSpPr>
-          <p:cNvPr id="6" name="Shape 4"/>
-          <p:cNvSpPr/>
-          <p:nvPr/>
-        </p:nvSpPr>
-        <p:spPr>
-          <a:xfrm>
-            <a:off x="4663440" y="1188720"/>
-            <a:ext cx="4023360" cy="2834640"/>
-          </a:xfrm>
-          <a:prstGeom prst="roundRect">
-            <a:avLst>
-              <a:gd name="adj" fmla="val 3226"/>
-            </a:avLst>
-          </a:prstGeom>
-          <a:solidFill>
-            <a:srgbClr val="134D3B"/>
-          </a:solidFill>
-          <a:ln w="12700">
-            <a:solidFill>
-              <a:srgbClr val="2A6B54"/>
-            </a:solidFill>
-            <a:prstDash val="solid"/>
-          </a:ln>
-        </p:spPr>
-      </p:sp>
-      <p:sp>
-        <p:nvSpPr>
-          <p:cNvPr id="7" name="Text 5"/>
+          <p:cNvPr id="9" name="Text 7"/>
           <p:cNvSpPr txBox="1"/>
           <p:nvPr/>
         </p:nvSpPr>
         <p:spPr>
           <a:xfrm>
-            <a:off x="4892040" y="1325880"/>
-            <a:ext cx="3566160" cy="365760"/>
+            <a:off x="457200" y="4297680"/>
+            <a:ext cx="8229600" cy="365760"/>
           </a:xfrm>
           <a:prstGeom prst="rect">
             <a:avLst/>
@@ -7819,131 +7569,7 @@
           <a:bodyPr wrap="square" lIns="0" tIns="0" rIns="0" bIns="0" rtlCol="0" anchor="ctr"/>
           <a:lstStyle/>
           <a:p>
-            <a:pPr indent="0" marL="0">
-              <a:buNone/>
-            </a:pPr>
-            <a:r>
-              <a:rPr lang="en-US" sz="2000" b="1" dirty="0">
-                <a:solidFill>
-                  <a:srgbClr val="F2B705"/>
-                </a:solidFill>
-                <a:latin typeface="Cambria" pitchFamily="34" charset="0"/>
-                <a:ea typeface="Cambria" pitchFamily="34" charset="-122"/>
-                <a:cs typeface="Cambria" pitchFamily="34" charset="-120"/>
-              </a:rPr>
-              <a:t>Lo que sigue</a:t>
-            </a:r>
-            <a:endParaRPr lang="en-US" sz="2000" dirty="0"/>
-          </a:p>
-        </p:txBody>
-      </p:sp>
-      <p:sp>
-        <p:nvSpPr>
-          <p:cNvPr id="8" name="Text 6"/>
-          <p:cNvSpPr txBox="1"/>
-          <p:nvPr/>
-        </p:nvSpPr>
-        <p:spPr>
-          <a:xfrm>
-            <a:off x="4892040" y="1783080"/>
-            <a:ext cx="3566160" cy="2560320"/>
-          </a:xfrm>
-          <a:prstGeom prst="rect">
-            <a:avLst/>
-          </a:prstGeom>
-          <a:noFill/>
-          <a:ln/>
-        </p:spPr>
-        <p:txBody>
-          <a:bodyPr wrap="square" lIns="0" tIns="0" rIns="0" bIns="0" rtlCol="0" anchor="t"/>
-          <a:lstStyle/>
-          <a:p>
-            <a:pPr marL="342900" indent="-342900">
-              <a:spcAft>
-                <a:spcPts val="600"/>
-              </a:spcAft>
-              <a:buSzPct val="100000"/>
-              <a:buChar char="•"/>
-            </a:pPr>
-            <a:r>
-              <a:rPr lang="en-US" sz="1400" dirty="0">
-                <a:solidFill>
-                  <a:srgbClr val="FFFFFF"/>
-                </a:solidFill>
-                <a:latin typeface="Calibri" pitchFamily="34" charset="0"/>
-                <a:ea typeface="Calibri" pitchFamily="34" charset="-122"/>
-                <a:cs typeface="Calibri" pitchFamily="34" charset="-120"/>
-              </a:rPr>
-              <a:t>Actualizar la tabla con los resultados de los partidos</a:t>
-            </a:r>
-            <a:endParaRPr lang="en-US" sz="1400" dirty="0"/>
-          </a:p>
-          <a:p>
-            <a:pPr marL="342900" indent="-342900">
-              <a:spcAft>
-                <a:spcPts val="600"/>
-              </a:spcAft>
-              <a:buSzPct val="100000"/>
-              <a:buChar char="•"/>
-            </a:pPr>
-            <a:r>
-              <a:rPr lang="en-US" sz="1400" dirty="0">
-                <a:solidFill>
-                  <a:srgbClr val="FFFFFF"/>
-                </a:solidFill>
-                <a:latin typeface="Calibri" pitchFamily="34" charset="0"/>
-                <a:ea typeface="Calibri" pitchFamily="34" charset="-122"/>
-                <a:cs typeface="Calibri" pitchFamily="34" charset="-120"/>
-              </a:rPr>
-              <a:t>Un menú principal que junte todo</a:t>
-            </a:r>
-            <a:endParaRPr lang="en-US" sz="1400" dirty="0"/>
-          </a:p>
-          <a:p>
-            <a:pPr marL="342900" indent="-342900">
-              <a:spcAft>
-                <a:spcPts val="600"/>
-              </a:spcAft>
-              <a:buSzPct val="100000"/>
-              <a:buChar char="•"/>
-            </a:pPr>
-            <a:r>
-              <a:rPr lang="en-US" sz="1400" dirty="0">
-                <a:solidFill>
-                  <a:srgbClr val="FFFFFF"/>
-                </a:solidFill>
-                <a:latin typeface="Calibri" pitchFamily="34" charset="0"/>
-                <a:ea typeface="Calibri" pitchFamily="34" charset="-122"/>
-                <a:cs typeface="Calibri" pitchFamily="34" charset="-120"/>
-              </a:rPr>
-              <a:t>Guardar y compartir los datos en un archivo TXT</a:t>
-            </a:r>
-            <a:endParaRPr lang="en-US" sz="1400" dirty="0"/>
-          </a:p>
-        </p:txBody>
-      </p:sp>
-      <p:sp>
-        <p:nvSpPr>
-          <p:cNvPr id="9" name="Text 7"/>
-          <p:cNvSpPr txBox="1"/>
-          <p:nvPr/>
-        </p:nvSpPr>
-        <p:spPr>
-          <a:xfrm>
-            <a:off x="457200" y="4297680"/>
-            <a:ext cx="8229600" cy="365760"/>
-          </a:xfrm>
-          <a:prstGeom prst="rect">
-            <a:avLst/>
-          </a:prstGeom>
-          <a:noFill/>
-          <a:ln/>
-        </p:spPr>
-        <p:txBody>
-          <a:bodyPr wrap="square" lIns="0" tIns="0" rIns="0" bIns="0" rtlCol="0" anchor="ctr"/>
-          <a:lstStyle/>
-          <a:p>
-            <a:pPr algn="ctr" indent="0" marL="0">
+            <a:pPr marL="0" indent="0" algn="ctr">
               <a:buNone/>
             </a:pPr>
             <a:r>
@@ -8262,4 +7888,319 @@
     </a:ext>
   </a:extLst>
 </a:theme>
+</file>
+
+<file path=ppt/theme/theme2.xml><?xml version="1.0" encoding="utf-8"?>
+<a:theme xmlns:a="http://schemas.openxmlformats.org/drawingml/2006/main" name="Tema de Office">
+  <a:themeElements>
+    <a:clrScheme name="Office">
+      <a:dk1>
+        <a:sysClr val="windowText" lastClr="000000"/>
+      </a:dk1>
+      <a:lt1>
+        <a:sysClr val="window" lastClr="FFFFFF"/>
+      </a:lt1>
+      <a:dk2>
+        <a:srgbClr val="0E2841"/>
+      </a:dk2>
+      <a:lt2>
+        <a:srgbClr val="E8E8E8"/>
+      </a:lt2>
+      <a:accent1>
+        <a:srgbClr val="156082"/>
+      </a:accent1>
+      <a:accent2>
+        <a:srgbClr val="E97132"/>
+      </a:accent2>
+      <a:accent3>
+        <a:srgbClr val="196B24"/>
+      </a:accent3>
+      <a:accent4>
+        <a:srgbClr val="0F9ED5"/>
+      </a:accent4>
+      <a:accent5>
+        <a:srgbClr val="A02B93"/>
+      </a:accent5>
+      <a:accent6>
+        <a:srgbClr val="4EA72E"/>
+      </a:accent6>
+      <a:hlink>
+        <a:srgbClr val="467886"/>
+      </a:hlink>
+      <a:folHlink>
+        <a:srgbClr val="96607D"/>
+      </a:folHlink>
+    </a:clrScheme>
+    <a:fontScheme name="Office">
+      <a:majorFont>
+        <a:latin typeface="Aptos Display" panose="02110004020202020204"/>
+        <a:ea typeface=""/>
+        <a:cs typeface=""/>
+        <a:font script="Jpan" typeface="游ゴシック Light"/>
+        <a:font script="Hang" typeface="맑은 고딕"/>
+        <a:font script="Hans" typeface="等线 Light"/>
+        <a:font script="Hant" typeface="新細明體"/>
+        <a:font script="Arab" typeface="Times New Roman"/>
+        <a:font script="Hebr" typeface="Times New Roman"/>
+        <a:font script="Thai" typeface="Angsana New"/>
+        <a:font script="Ethi" typeface="Nyala"/>
+        <a:font script="Beng" typeface="Vrinda"/>
+        <a:font script="Gujr" typeface="Shruti"/>
+        <a:font script="Khmr" typeface="MoolBoran"/>
+        <a:font script="Knda" typeface="Tunga"/>
+        <a:font script="Guru" typeface="Raavi"/>
+        <a:font script="Cans" typeface="Euphemia"/>
+        <a:font script="Cher" typeface="Plantagenet Cherokee"/>
+        <a:font script="Yiii" typeface="Microsoft Yi Baiti"/>
+        <a:font script="Tibt" typeface="Microsoft Himalaya"/>
+        <a:font script="Thaa" typeface="MV Boli"/>
+        <a:font script="Deva" typeface="Mangal"/>
+        <a:font script="Telu" typeface="Gautami"/>
+        <a:font script="Taml" typeface="Latha"/>
+        <a:font script="Syrc" typeface="Estrangelo Edessa"/>
+        <a:font script="Orya" typeface="Kalinga"/>
+        <a:font script="Mlym" typeface="Kartika"/>
+        <a:font script="Laoo" typeface="DokChampa"/>
+        <a:font script="Sinh" typeface="Iskoola Pota"/>
+        <a:font script="Mong" typeface="Mongolian Baiti"/>
+        <a:font script="Viet" typeface="Times New Roman"/>
+        <a:font script="Uigh" typeface="Microsoft Uighur"/>
+        <a:font script="Geor" typeface="Sylfaen"/>
+        <a:font script="Armn" typeface="Arial"/>
+        <a:font script="Bugi" typeface="Leelawadee UI"/>
+        <a:font script="Bopo" typeface="Microsoft JhengHei"/>
+        <a:font script="Java" typeface="Javanese Text"/>
+        <a:font script="Lisu" typeface="Segoe UI"/>
+        <a:font script="Mymr" typeface="Myanmar Text"/>
+        <a:font script="Nkoo" typeface="Ebrima"/>
+        <a:font script="Olck" typeface="Nirmala UI"/>
+        <a:font script="Osma" typeface="Ebrima"/>
+        <a:font script="Phag" typeface="Phagspa"/>
+        <a:font script="Syrn" typeface="Estrangelo Edessa"/>
+        <a:font script="Syrj" typeface="Estrangelo Edessa"/>
+        <a:font script="Syre" typeface="Estrangelo Edessa"/>
+        <a:font script="Sora" typeface="Nirmala UI"/>
+        <a:font script="Tale" typeface="Microsoft Tai Le"/>
+        <a:font script="Talu" typeface="Microsoft New Tai Lue"/>
+        <a:font script="Tfng" typeface="Ebrima"/>
+      </a:majorFont>
+      <a:minorFont>
+        <a:latin typeface="Aptos" panose="02110004020202020204"/>
+        <a:ea typeface=""/>
+        <a:cs typeface=""/>
+        <a:font script="Jpan" typeface="游ゴシック"/>
+        <a:font script="Hang" typeface="맑은 고딕"/>
+        <a:font script="Hans" typeface="等线"/>
+        <a:font script="Hant" typeface="新細明體"/>
+        <a:font script="Arab" typeface="Arial"/>
+        <a:font script="Hebr" typeface="Arial"/>
+        <a:font script="Thai" typeface="Cordia New"/>
+        <a:font script="Ethi" typeface="Nyala"/>
+        <a:font script="Beng" typeface="Vrinda"/>
+        <a:font script="Gujr" typeface="Shruti"/>
+        <a:font script="Khmr" typeface="DaunPenh"/>
+        <a:font script="Knda" typeface="Tunga"/>
+        <a:font script="Guru" typeface="Raavi"/>
+        <a:font script="Cans" typeface="Euphemia"/>
+        <a:font script="Cher" typeface="Plantagenet Cherokee"/>
+        <a:font script="Yiii" typeface="Microsoft Yi Baiti"/>
+        <a:font script="Tibt" typeface="Microsoft Himalaya"/>
+        <a:font script="Thaa" typeface="MV Boli"/>
+        <a:font script="Deva" typeface="Mangal"/>
+        <a:font script="Telu" typeface="Gautami"/>
+        <a:font script="Taml" typeface="Latha"/>
+        <a:font script="Syrc" typeface="Estrangelo Edessa"/>
+        <a:font script="Orya" typeface="Kalinga"/>
+        <a:font script="Mlym" typeface="Kartika"/>
+        <a:font script="Laoo" typeface="DokChampa"/>
+        <a:font script="Sinh" typeface="Iskoola Pota"/>
+        <a:font script="Mong" typeface="Mongolian Baiti"/>
+        <a:font script="Viet" typeface="Arial"/>
+        <a:font script="Uigh" typeface="Microsoft Uighur"/>
+        <a:font script="Geor" typeface="Sylfaen"/>
+        <a:font script="Armn" typeface="Arial"/>
+        <a:font script="Bugi" typeface="Leelawadee UI"/>
+        <a:font script="Bopo" typeface="Microsoft JhengHei"/>
+        <a:font script="Java" typeface="Javanese Text"/>
+        <a:font script="Lisu" typeface="Segoe UI"/>
+        <a:font script="Mymr" typeface="Myanmar Text"/>
+        <a:font script="Nkoo" typeface="Ebrima"/>
+        <a:font script="Olck" typeface="Nirmala UI"/>
+        <a:font script="Osma" typeface="Ebrima"/>
+        <a:font script="Phag" typeface="Phagspa"/>
+        <a:font script="Syrn" typeface="Estrangelo Edessa"/>
+        <a:font script="Syrj" typeface="Estrangelo Edessa"/>
+        <a:font script="Syre" typeface="Estrangelo Edessa"/>
+        <a:font script="Sora" typeface="Nirmala UI"/>
+        <a:font script="Tale" typeface="Microsoft Tai Le"/>
+        <a:font script="Talu" typeface="Microsoft New Tai Lue"/>
+        <a:font script="Tfng" typeface="Ebrima"/>
+      </a:minorFont>
+    </a:fontScheme>
+    <a:fmtScheme name="Office">
+      <a:fillStyleLst>
+        <a:solidFill>
+          <a:schemeClr val="phClr"/>
+        </a:solidFill>
+        <a:gradFill rotWithShape="1">
+          <a:gsLst>
+            <a:gs pos="0">
+              <a:schemeClr val="phClr">
+                <a:lumMod val="110000"/>
+                <a:satMod val="105000"/>
+                <a:tint val="67000"/>
+              </a:schemeClr>
+            </a:gs>
+            <a:gs pos="50000">
+              <a:schemeClr val="phClr">
+                <a:lumMod val="105000"/>
+                <a:satMod val="103000"/>
+                <a:tint val="73000"/>
+              </a:schemeClr>
+            </a:gs>
+            <a:gs pos="100000">
+              <a:schemeClr val="phClr">
+                <a:lumMod val="105000"/>
+                <a:satMod val="109000"/>
+                <a:tint val="81000"/>
+              </a:schemeClr>
+            </a:gs>
+          </a:gsLst>
+          <a:lin ang="5400000" scaled="0"/>
+        </a:gradFill>
+        <a:gradFill rotWithShape="1">
+          <a:gsLst>
+            <a:gs pos="0">
+              <a:schemeClr val="phClr">
+                <a:satMod val="103000"/>
+                <a:lumMod val="102000"/>
+                <a:tint val="94000"/>
+              </a:schemeClr>
+            </a:gs>
+            <a:gs pos="50000">
+              <a:schemeClr val="phClr">
+                <a:satMod val="110000"/>
+                <a:lumMod val="100000"/>
+                <a:shade val="100000"/>
+              </a:schemeClr>
+            </a:gs>
+            <a:gs pos="100000">
+              <a:schemeClr val="phClr">
+                <a:lumMod val="99000"/>
+                <a:satMod val="120000"/>
+                <a:shade val="78000"/>
+              </a:schemeClr>
+            </a:gs>
+          </a:gsLst>
+          <a:lin ang="5400000" scaled="0"/>
+        </a:gradFill>
+      </a:fillStyleLst>
+      <a:lnStyleLst>
+        <a:ln w="12700" cap="flat" cmpd="sng" algn="ctr">
+          <a:solidFill>
+            <a:schemeClr val="phClr"/>
+          </a:solidFill>
+          <a:prstDash val="solid"/>
+          <a:miter lim="800000"/>
+        </a:ln>
+        <a:ln w="19050" cap="flat" cmpd="sng" algn="ctr">
+          <a:solidFill>
+            <a:schemeClr val="phClr"/>
+          </a:solidFill>
+          <a:prstDash val="solid"/>
+          <a:miter lim="800000"/>
+        </a:ln>
+        <a:ln w="25400" cap="flat" cmpd="sng" algn="ctr">
+          <a:solidFill>
+            <a:schemeClr val="phClr"/>
+          </a:solidFill>
+          <a:prstDash val="solid"/>
+          <a:miter lim="800000"/>
+        </a:ln>
+      </a:lnStyleLst>
+      <a:effectStyleLst>
+        <a:effectStyle>
+          <a:effectLst/>
+        </a:effectStyle>
+        <a:effectStyle>
+          <a:effectLst/>
+        </a:effectStyle>
+        <a:effectStyle>
+          <a:effectLst>
+            <a:outerShdw blurRad="57150" dist="19050" dir="5400000" algn="ctr" rotWithShape="0">
+              <a:srgbClr val="000000">
+                <a:alpha val="63000"/>
+              </a:srgbClr>
+            </a:outerShdw>
+          </a:effectLst>
+        </a:effectStyle>
+      </a:effectStyleLst>
+      <a:bgFillStyleLst>
+        <a:solidFill>
+          <a:schemeClr val="phClr"/>
+        </a:solidFill>
+        <a:solidFill>
+          <a:schemeClr val="phClr">
+            <a:tint val="95000"/>
+            <a:satMod val="170000"/>
+          </a:schemeClr>
+        </a:solidFill>
+        <a:gradFill rotWithShape="1">
+          <a:gsLst>
+            <a:gs pos="0">
+              <a:schemeClr val="phClr">
+                <a:tint val="93000"/>
+                <a:satMod val="150000"/>
+                <a:shade val="98000"/>
+                <a:lumMod val="102000"/>
+              </a:schemeClr>
+            </a:gs>
+            <a:gs pos="50000">
+              <a:schemeClr val="phClr">
+                <a:tint val="98000"/>
+                <a:satMod val="130000"/>
+                <a:shade val="90000"/>
+                <a:lumMod val="103000"/>
+              </a:schemeClr>
+            </a:gs>
+            <a:gs pos="100000">
+              <a:schemeClr val="phClr">
+                <a:shade val="63000"/>
+                <a:satMod val="120000"/>
+              </a:schemeClr>
+            </a:gs>
+          </a:gsLst>
+          <a:lin ang="5400000" scaled="0"/>
+        </a:gradFill>
+      </a:bgFillStyleLst>
+    </a:fmtScheme>
+  </a:themeElements>
+  <a:objectDefaults>
+    <a:lnDef>
+      <a:spPr/>
+      <a:bodyPr/>
+      <a:lstStyle/>
+      <a:style>
+        <a:lnRef idx="2">
+          <a:schemeClr val="accent1"/>
+        </a:lnRef>
+        <a:fillRef idx="0">
+          <a:schemeClr val="accent1"/>
+        </a:fillRef>
+        <a:effectRef idx="1">
+          <a:schemeClr val="accent1"/>
+        </a:effectRef>
+        <a:fontRef idx="minor">
+          <a:schemeClr val="tx1"/>
+        </a:fontRef>
+      </a:style>
+    </a:lnDef>
+  </a:objectDefaults>
+  <a:extraClrSchemeLst/>
+  <a:extLst>
+    <a:ext uri="{05A4C25C-085E-4340-85A3-A5531E510DB2}">
+      <thm15:themeFamily xmlns:thm15="http://schemas.microsoft.com/office/thememl/2012/main" name="Office Theme" id="{2E142A2C-CD16-42D6-873A-C26D2A0506FA}" vid="{1BDDFF52-6CD6-40A5-AB3C-68EB2F1E4D0A}"/>
+    </a:ext>
+  </a:extLst>
+</a:theme>
 </file>
</xml_diff>